<commit_message>
docs: fix layout EN presentation (row heights, formula box)
</commit_message>
<xml_diff>
--- a/docs/presentations/EN_EEG_Project_Status_Mar2026.pptx
+++ b/docs/presentations/EN_EEG_Project_Status_Mar2026.pptx
@@ -4711,7 +4711,7 @@
         <p:spPr>
           <a:xfrm>
             <a:off x="365760" y="1444752"/>
-            <a:ext cx="8412480" cy="393192"/>
+            <a:ext cx="8412480" cy="420624"/>
           </a:xfrm>
           <a:prstGeom prst="rect">
             <a:avLst/>
@@ -4930,8 +4930,8 @@
         </p:nvSpPr>
         <p:spPr>
           <a:xfrm>
-            <a:off x="365760" y="1874520"/>
-            <a:ext cx="8412480" cy="393192"/>
+            <a:off x="365760" y="1901952"/>
+            <a:ext cx="8412480" cy="420624"/>
           </a:xfrm>
           <a:prstGeom prst="rect">
             <a:avLst/>
@@ -4955,7 +4955,7 @@
         </p:nvSpPr>
         <p:spPr>
           <a:xfrm>
-            <a:off x="365760" y="1929384"/>
+            <a:off x="365760" y="1956816"/>
             <a:ext cx="914400" cy="274320"/>
           </a:xfrm>
           <a:prstGeom prst="rect">
@@ -4994,7 +4994,7 @@
         </p:nvSpPr>
         <p:spPr>
           <a:xfrm>
-            <a:off x="1325880" y="1929384"/>
+            <a:off x="1325880" y="1956816"/>
             <a:ext cx="365760" cy="274320"/>
           </a:xfrm>
           <a:prstGeom prst="rect">
@@ -5033,7 +5033,7 @@
         </p:nvSpPr>
         <p:spPr>
           <a:xfrm>
-            <a:off x="1737360" y="1929384"/>
+            <a:off x="1737360" y="1956816"/>
             <a:ext cx="1371600" cy="274320"/>
           </a:xfrm>
           <a:prstGeom prst="rect">
@@ -5072,7 +5072,7 @@
         </p:nvSpPr>
         <p:spPr>
           <a:xfrm>
-            <a:off x="3154680" y="1929384"/>
+            <a:off x="3154680" y="1956816"/>
             <a:ext cx="3840480" cy="274320"/>
           </a:xfrm>
           <a:prstGeom prst="rect">
@@ -5111,7 +5111,7 @@
         </p:nvSpPr>
         <p:spPr>
           <a:xfrm>
-            <a:off x="7040880" y="1929384"/>
+            <a:off x="7040880" y="1956816"/>
             <a:ext cx="731520" cy="274320"/>
           </a:xfrm>
           <a:prstGeom prst="rect">
@@ -5150,8 +5150,8 @@
         </p:nvSpPr>
         <p:spPr>
           <a:xfrm>
-            <a:off x="365760" y="2304288"/>
-            <a:ext cx="8412480" cy="393192"/>
+            <a:off x="365760" y="2359152"/>
+            <a:ext cx="8412480" cy="420624"/>
           </a:xfrm>
           <a:prstGeom prst="rect">
             <a:avLst/>
@@ -5175,7 +5175,7 @@
         </p:nvSpPr>
         <p:spPr>
           <a:xfrm>
-            <a:off x="365760" y="2359152"/>
+            <a:off x="365760" y="2414016"/>
             <a:ext cx="914400" cy="274320"/>
           </a:xfrm>
           <a:prstGeom prst="rect">
@@ -5214,7 +5214,7 @@
         </p:nvSpPr>
         <p:spPr>
           <a:xfrm>
-            <a:off x="1325880" y="2359152"/>
+            <a:off x="1325880" y="2414016"/>
             <a:ext cx="365760" cy="274320"/>
           </a:xfrm>
           <a:prstGeom prst="rect">
@@ -5253,7 +5253,7 @@
         </p:nvSpPr>
         <p:spPr>
           <a:xfrm>
-            <a:off x="1737360" y="2359152"/>
+            <a:off x="1737360" y="2414016"/>
             <a:ext cx="1371600" cy="274320"/>
           </a:xfrm>
           <a:prstGeom prst="rect">
@@ -5292,7 +5292,7 @@
         </p:nvSpPr>
         <p:spPr>
           <a:xfrm>
-            <a:off x="3154680" y="2359152"/>
+            <a:off x="3154680" y="2414016"/>
             <a:ext cx="3840480" cy="274320"/>
           </a:xfrm>
           <a:prstGeom prst="rect">
@@ -5331,7 +5331,7 @@
         </p:nvSpPr>
         <p:spPr>
           <a:xfrm>
-            <a:off x="7040880" y="2359152"/>
+            <a:off x="7040880" y="2414016"/>
             <a:ext cx="731520" cy="274320"/>
           </a:xfrm>
           <a:prstGeom prst="rect">
@@ -5370,8 +5370,8 @@
         </p:nvSpPr>
         <p:spPr>
           <a:xfrm>
-            <a:off x="365760" y="2734056"/>
-            <a:ext cx="8412480" cy="393192"/>
+            <a:off x="365760" y="2816352"/>
+            <a:ext cx="8412480" cy="420624"/>
           </a:xfrm>
           <a:prstGeom prst="rect">
             <a:avLst/>
@@ -5395,7 +5395,7 @@
         </p:nvSpPr>
         <p:spPr>
           <a:xfrm>
-            <a:off x="365760" y="2788920"/>
+            <a:off x="365760" y="2871216"/>
             <a:ext cx="914400" cy="274320"/>
           </a:xfrm>
           <a:prstGeom prst="rect">
@@ -5434,7 +5434,7 @@
         </p:nvSpPr>
         <p:spPr>
           <a:xfrm>
-            <a:off x="1325880" y="2788920"/>
+            <a:off x="1325880" y="2871216"/>
             <a:ext cx="365760" cy="274320"/>
           </a:xfrm>
           <a:prstGeom prst="rect">
@@ -5473,7 +5473,7 @@
         </p:nvSpPr>
         <p:spPr>
           <a:xfrm>
-            <a:off x="1737360" y="2788920"/>
+            <a:off x="1737360" y="2871216"/>
             <a:ext cx="1371600" cy="274320"/>
           </a:xfrm>
           <a:prstGeom prst="rect">
@@ -5512,7 +5512,7 @@
         </p:nvSpPr>
         <p:spPr>
           <a:xfrm>
-            <a:off x="3154680" y="2788920"/>
+            <a:off x="3154680" y="2871216"/>
             <a:ext cx="3840480" cy="274320"/>
           </a:xfrm>
           <a:prstGeom prst="rect">
@@ -5551,7 +5551,7 @@
         </p:nvSpPr>
         <p:spPr>
           <a:xfrm>
-            <a:off x="7040880" y="2788920"/>
+            <a:off x="7040880" y="2871216"/>
             <a:ext cx="731520" cy="274320"/>
           </a:xfrm>
           <a:prstGeom prst="rect">
@@ -5590,8 +5590,8 @@
         </p:nvSpPr>
         <p:spPr>
           <a:xfrm>
-            <a:off x="365760" y="3163824"/>
-            <a:ext cx="8412480" cy="393192"/>
+            <a:off x="365760" y="3273552"/>
+            <a:ext cx="8412480" cy="420624"/>
           </a:xfrm>
           <a:prstGeom prst="rect">
             <a:avLst/>
@@ -5615,7 +5615,7 @@
         </p:nvSpPr>
         <p:spPr>
           <a:xfrm>
-            <a:off x="365760" y="3218688"/>
+            <a:off x="365760" y="3328416"/>
             <a:ext cx="914400" cy="274320"/>
           </a:xfrm>
           <a:prstGeom prst="rect">
@@ -5654,7 +5654,7 @@
         </p:nvSpPr>
         <p:spPr>
           <a:xfrm>
-            <a:off x="1325880" y="3218688"/>
+            <a:off x="1325880" y="3328416"/>
             <a:ext cx="365760" cy="274320"/>
           </a:xfrm>
           <a:prstGeom prst="rect">
@@ -5693,7 +5693,7 @@
         </p:nvSpPr>
         <p:spPr>
           <a:xfrm>
-            <a:off x="1737360" y="3218688"/>
+            <a:off x="1737360" y="3328416"/>
             <a:ext cx="1371600" cy="274320"/>
           </a:xfrm>
           <a:prstGeom prst="rect">
@@ -5732,7 +5732,7 @@
         </p:nvSpPr>
         <p:spPr>
           <a:xfrm>
-            <a:off x="3154680" y="3218688"/>
+            <a:off x="3154680" y="3328416"/>
             <a:ext cx="3840480" cy="274320"/>
           </a:xfrm>
           <a:prstGeom prst="rect">
@@ -5771,7 +5771,7 @@
         </p:nvSpPr>
         <p:spPr>
           <a:xfrm>
-            <a:off x="7040880" y="3218688"/>
+            <a:off x="7040880" y="3328416"/>
             <a:ext cx="731520" cy="274320"/>
           </a:xfrm>
           <a:prstGeom prst="rect">
@@ -5810,8 +5810,8 @@
         </p:nvSpPr>
         <p:spPr>
           <a:xfrm>
-            <a:off x="365760" y="3593592"/>
-            <a:ext cx="8412480" cy="393192"/>
+            <a:off x="365760" y="3730752"/>
+            <a:ext cx="8412480" cy="420624"/>
           </a:xfrm>
           <a:prstGeom prst="rect">
             <a:avLst/>
@@ -5835,7 +5835,7 @@
         </p:nvSpPr>
         <p:spPr>
           <a:xfrm>
-            <a:off x="365760" y="3648456"/>
+            <a:off x="365760" y="3785616"/>
             <a:ext cx="914400" cy="274320"/>
           </a:xfrm>
           <a:prstGeom prst="rect">
@@ -5874,7 +5874,7 @@
         </p:nvSpPr>
         <p:spPr>
           <a:xfrm>
-            <a:off x="1325880" y="3648456"/>
+            <a:off x="1325880" y="3785616"/>
             <a:ext cx="365760" cy="274320"/>
           </a:xfrm>
           <a:prstGeom prst="rect">
@@ -5913,7 +5913,7 @@
         </p:nvSpPr>
         <p:spPr>
           <a:xfrm>
-            <a:off x="1737360" y="3648456"/>
+            <a:off x="1737360" y="3785616"/>
             <a:ext cx="1371600" cy="274320"/>
           </a:xfrm>
           <a:prstGeom prst="rect">
@@ -5952,7 +5952,7 @@
         </p:nvSpPr>
         <p:spPr>
           <a:xfrm>
-            <a:off x="3154680" y="3648456"/>
+            <a:off x="3154680" y="3785616"/>
             <a:ext cx="3840480" cy="274320"/>
           </a:xfrm>
           <a:prstGeom prst="rect">
@@ -5991,7 +5991,7 @@
         </p:nvSpPr>
         <p:spPr>
           <a:xfrm>
-            <a:off x="7040880" y="3648456"/>
+            <a:off x="7040880" y="3785616"/>
             <a:ext cx="731520" cy="274320"/>
           </a:xfrm>
           <a:prstGeom prst="rect">
@@ -6030,7 +6030,7 @@
         </p:nvSpPr>
         <p:spPr>
           <a:xfrm>
-            <a:off x="365760" y="3593592"/>
+            <a:off x="365760" y="3730752"/>
             <a:ext cx="54864" cy="393192"/>
           </a:xfrm>
           <a:prstGeom prst="rect">
@@ -6055,8 +6055,8 @@
         </p:nvSpPr>
         <p:spPr>
           <a:xfrm>
-            <a:off x="365760" y="4023360"/>
-            <a:ext cx="8412480" cy="393192"/>
+            <a:off x="365760" y="4187952"/>
+            <a:ext cx="8412480" cy="420624"/>
           </a:xfrm>
           <a:prstGeom prst="rect">
             <a:avLst/>
@@ -6080,7 +6080,7 @@
         </p:nvSpPr>
         <p:spPr>
           <a:xfrm>
-            <a:off x="365760" y="4078224"/>
+            <a:off x="365760" y="4242816"/>
             <a:ext cx="914400" cy="274320"/>
           </a:xfrm>
           <a:prstGeom prst="rect">
@@ -6119,7 +6119,7 @@
         </p:nvSpPr>
         <p:spPr>
           <a:xfrm>
-            <a:off x="1325880" y="4078224"/>
+            <a:off x="1325880" y="4242816"/>
             <a:ext cx="365760" cy="274320"/>
           </a:xfrm>
           <a:prstGeom prst="rect">
@@ -6158,7 +6158,7 @@
         </p:nvSpPr>
         <p:spPr>
           <a:xfrm>
-            <a:off x="1737360" y="4078224"/>
+            <a:off x="1737360" y="4242816"/>
             <a:ext cx="1371600" cy="274320"/>
           </a:xfrm>
           <a:prstGeom prst="rect">
@@ -6197,7 +6197,7 @@
         </p:nvSpPr>
         <p:spPr>
           <a:xfrm>
-            <a:off x="3154680" y="4078224"/>
+            <a:off x="3154680" y="4242816"/>
             <a:ext cx="3840480" cy="274320"/>
           </a:xfrm>
           <a:prstGeom prst="rect">
@@ -6236,7 +6236,7 @@
         </p:nvSpPr>
         <p:spPr>
           <a:xfrm>
-            <a:off x="7040880" y="4078224"/>
+            <a:off x="7040880" y="4242816"/>
             <a:ext cx="731520" cy="274320"/>
           </a:xfrm>
           <a:prstGeom prst="rect">
@@ -6275,7 +6275,7 @@
         </p:nvSpPr>
         <p:spPr>
           <a:xfrm>
-            <a:off x="365760" y="4023360"/>
+            <a:off x="365760" y="4187952"/>
             <a:ext cx="54864" cy="393192"/>
           </a:xfrm>
           <a:prstGeom prst="rect">
@@ -9258,7 +9258,7 @@
         <p:spPr>
           <a:xfrm>
             <a:off x="365760" y="1920240"/>
-            <a:ext cx="8412480" cy="365760"/>
+            <a:ext cx="8412480" cy="347472"/>
           </a:xfrm>
           <a:prstGeom prst="rect">
             <a:avLst/>
@@ -9438,8 +9438,8 @@
         </p:nvSpPr>
         <p:spPr>
           <a:xfrm>
-            <a:off x="365760" y="2322576"/>
-            <a:ext cx="8412480" cy="365760"/>
+            <a:off x="365760" y="2304288"/>
+            <a:ext cx="8412480" cy="347472"/>
           </a:xfrm>
           <a:prstGeom prst="rect">
             <a:avLst/>
@@ -9463,7 +9463,7 @@
         </p:nvSpPr>
         <p:spPr>
           <a:xfrm>
-            <a:off x="365760" y="2377440"/>
+            <a:off x="365760" y="2359152"/>
             <a:ext cx="2926080" cy="256032"/>
           </a:xfrm>
           <a:prstGeom prst="rect">
@@ -9502,7 +9502,7 @@
         </p:nvSpPr>
         <p:spPr>
           <a:xfrm>
-            <a:off x="3474720" y="2377440"/>
+            <a:off x="3474720" y="2359152"/>
             <a:ext cx="1645920" cy="256032"/>
           </a:xfrm>
           <a:prstGeom prst="rect">
@@ -9541,7 +9541,7 @@
         </p:nvSpPr>
         <p:spPr>
           <a:xfrm>
-            <a:off x="5303520" y="2377440"/>
+            <a:off x="5303520" y="2359152"/>
             <a:ext cx="1645920" cy="256032"/>
           </a:xfrm>
           <a:prstGeom prst="rect">
@@ -9580,7 +9580,7 @@
         </p:nvSpPr>
         <p:spPr>
           <a:xfrm>
-            <a:off x="6858000" y="2377440"/>
+            <a:off x="6858000" y="2359152"/>
             <a:ext cx="1828800" cy="256032"/>
           </a:xfrm>
           <a:prstGeom prst="rect">
@@ -9619,8 +9619,8 @@
         </p:nvSpPr>
         <p:spPr>
           <a:xfrm>
-            <a:off x="365760" y="2724912"/>
-            <a:ext cx="8412480" cy="365760"/>
+            <a:off x="365760" y="2688336"/>
+            <a:ext cx="8412480" cy="347472"/>
           </a:xfrm>
           <a:prstGeom prst="rect">
             <a:avLst/>
@@ -9644,7 +9644,7 @@
         </p:nvSpPr>
         <p:spPr>
           <a:xfrm>
-            <a:off x="365760" y="2779776"/>
+            <a:off x="365760" y="2743200"/>
             <a:ext cx="2926080" cy="256032"/>
           </a:xfrm>
           <a:prstGeom prst="rect">
@@ -9683,7 +9683,7 @@
         </p:nvSpPr>
         <p:spPr>
           <a:xfrm>
-            <a:off x="3474720" y="2779776"/>
+            <a:off x="3474720" y="2743200"/>
             <a:ext cx="1645920" cy="256032"/>
           </a:xfrm>
           <a:prstGeom prst="rect">
@@ -9722,7 +9722,7 @@
         </p:nvSpPr>
         <p:spPr>
           <a:xfrm>
-            <a:off x="5303520" y="2779776"/>
+            <a:off x="5303520" y="2743200"/>
             <a:ext cx="1645920" cy="256032"/>
           </a:xfrm>
           <a:prstGeom prst="rect">
@@ -9761,7 +9761,7 @@
         </p:nvSpPr>
         <p:spPr>
           <a:xfrm>
-            <a:off x="6858000" y="2779776"/>
+            <a:off x="6858000" y="2743200"/>
             <a:ext cx="1828800" cy="256032"/>
           </a:xfrm>
           <a:prstGeom prst="rect">
@@ -9800,8 +9800,8 @@
         </p:nvSpPr>
         <p:spPr>
           <a:xfrm>
-            <a:off x="365760" y="3127248"/>
-            <a:ext cx="8412480" cy="365760"/>
+            <a:off x="365760" y="3072384"/>
+            <a:ext cx="8412480" cy="347472"/>
           </a:xfrm>
           <a:prstGeom prst="rect">
             <a:avLst/>
@@ -9825,7 +9825,7 @@
         </p:nvSpPr>
         <p:spPr>
           <a:xfrm>
-            <a:off x="365760" y="3182112"/>
+            <a:off x="365760" y="3127248"/>
             <a:ext cx="2926080" cy="256032"/>
           </a:xfrm>
           <a:prstGeom prst="rect">
@@ -9864,7 +9864,7 @@
         </p:nvSpPr>
         <p:spPr>
           <a:xfrm>
-            <a:off x="3474720" y="3182112"/>
+            <a:off x="3474720" y="3127248"/>
             <a:ext cx="1645920" cy="256032"/>
           </a:xfrm>
           <a:prstGeom prst="rect">
@@ -9903,7 +9903,7 @@
         </p:nvSpPr>
         <p:spPr>
           <a:xfrm>
-            <a:off x="5303520" y="3182112"/>
+            <a:off x="5303520" y="3127248"/>
             <a:ext cx="1645920" cy="256032"/>
           </a:xfrm>
           <a:prstGeom prst="rect">
@@ -9942,7 +9942,7 @@
         </p:nvSpPr>
         <p:spPr>
           <a:xfrm>
-            <a:off x="6858000" y="3182112"/>
+            <a:off x="6858000" y="3127248"/>
             <a:ext cx="1828800" cy="256032"/>
           </a:xfrm>
           <a:prstGeom prst="rect">
@@ -9981,8 +9981,8 @@
         </p:nvSpPr>
         <p:spPr>
           <a:xfrm>
-            <a:off x="365760" y="3529584"/>
-            <a:ext cx="8412480" cy="365760"/>
+            <a:off x="365760" y="3456432"/>
+            <a:ext cx="8412480" cy="347472"/>
           </a:xfrm>
           <a:prstGeom prst="rect">
             <a:avLst/>
@@ -10006,7 +10006,7 @@
         </p:nvSpPr>
         <p:spPr>
           <a:xfrm>
-            <a:off x="365760" y="3584448"/>
+            <a:off x="365760" y="3511296"/>
             <a:ext cx="2926080" cy="256032"/>
           </a:xfrm>
           <a:prstGeom prst="rect">
@@ -10045,7 +10045,7 @@
         </p:nvSpPr>
         <p:spPr>
           <a:xfrm>
-            <a:off x="3474720" y="3584448"/>
+            <a:off x="3474720" y="3511296"/>
             <a:ext cx="1645920" cy="256032"/>
           </a:xfrm>
           <a:prstGeom prst="rect">
@@ -10084,7 +10084,7 @@
         </p:nvSpPr>
         <p:spPr>
           <a:xfrm>
-            <a:off x="5303520" y="3584448"/>
+            <a:off x="5303520" y="3511296"/>
             <a:ext cx="1645920" cy="256032"/>
           </a:xfrm>
           <a:prstGeom prst="rect">
@@ -10123,7 +10123,7 @@
         </p:nvSpPr>
         <p:spPr>
           <a:xfrm>
-            <a:off x="6858000" y="3584448"/>
+            <a:off x="6858000" y="3511296"/>
             <a:ext cx="1828800" cy="256032"/>
           </a:xfrm>
           <a:prstGeom prst="rect">
@@ -10162,8 +10162,8 @@
         </p:nvSpPr>
         <p:spPr>
           <a:xfrm>
-            <a:off x="365760" y="3931920"/>
-            <a:ext cx="8412480" cy="365760"/>
+            <a:off x="365760" y="3840480"/>
+            <a:ext cx="8412480" cy="347472"/>
           </a:xfrm>
           <a:prstGeom prst="rect">
             <a:avLst/>
@@ -10187,7 +10187,7 @@
         </p:nvSpPr>
         <p:spPr>
           <a:xfrm>
-            <a:off x="365760" y="3986784"/>
+            <a:off x="365760" y="3895344"/>
             <a:ext cx="2926080" cy="256032"/>
           </a:xfrm>
           <a:prstGeom prst="rect">
@@ -10226,7 +10226,7 @@
         </p:nvSpPr>
         <p:spPr>
           <a:xfrm>
-            <a:off x="3474720" y="3986784"/>
+            <a:off x="3474720" y="3895344"/>
             <a:ext cx="1645920" cy="256032"/>
           </a:xfrm>
           <a:prstGeom prst="rect">
@@ -10265,7 +10265,7 @@
         </p:nvSpPr>
         <p:spPr>
           <a:xfrm>
-            <a:off x="5303520" y="3986784"/>
+            <a:off x="5303520" y="3895344"/>
             <a:ext cx="1645920" cy="256032"/>
           </a:xfrm>
           <a:prstGeom prst="rect">
@@ -10304,7 +10304,7 @@
         </p:nvSpPr>
         <p:spPr>
           <a:xfrm>
-            <a:off x="6858000" y="3986784"/>
+            <a:off x="6858000" y="3895344"/>
             <a:ext cx="1828800" cy="256032"/>
           </a:xfrm>
           <a:prstGeom prst="rect">
@@ -10569,8 +10569,8 @@
         </p:nvSpPr>
         <p:spPr>
           <a:xfrm>
-            <a:off x="2286000" y="1051560"/>
-            <a:ext cx="4572000" cy="502920"/>
+            <a:off x="1371600" y="1051560"/>
+            <a:ext cx="6400800" cy="502920"/>
           </a:xfrm>
           <a:prstGeom prst="roundRect">
             <a:avLst>
@@ -10596,8 +10596,8 @@
         </p:nvSpPr>
         <p:spPr>
           <a:xfrm>
-            <a:off x="2286000" y="1097280"/>
-            <a:ext cx="4572000" cy="384048"/>
+            <a:off x="1371600" y="1097280"/>
+            <a:ext cx="6400800" cy="384048"/>
           </a:xfrm>
           <a:prstGeom prst="rect">
             <a:avLst/>
@@ -10997,7 +10997,7 @@
         </p:nvSpPr>
         <p:spPr>
           <a:xfrm>
-            <a:off x="365760" y="2459736"/>
+            <a:off x="365760" y="2496312"/>
             <a:ext cx="8412480" cy="347472"/>
           </a:xfrm>
           <a:prstGeom prst="rect">
@@ -11022,7 +11022,7 @@
         </p:nvSpPr>
         <p:spPr>
           <a:xfrm>
-            <a:off x="365760" y="2505456"/>
+            <a:off x="365760" y="2542032"/>
             <a:ext cx="2743200" cy="256032"/>
           </a:xfrm>
           <a:prstGeom prst="rect">
@@ -11061,7 +11061,7 @@
         </p:nvSpPr>
         <p:spPr>
           <a:xfrm>
-            <a:off x="3200400" y="2505456"/>
+            <a:off x="3200400" y="2542032"/>
             <a:ext cx="1645920" cy="256032"/>
           </a:xfrm>
           <a:prstGeom prst="rect">
@@ -11100,7 +11100,7 @@
         </p:nvSpPr>
         <p:spPr>
           <a:xfrm>
-            <a:off x="5029200" y="2505456"/>
+            <a:off x="5029200" y="2542032"/>
             <a:ext cx="1645920" cy="256032"/>
           </a:xfrm>
           <a:prstGeom prst="rect">
@@ -11139,7 +11139,7 @@
         </p:nvSpPr>
         <p:spPr>
           <a:xfrm>
-            <a:off x="7132320" y="2505456"/>
+            <a:off x="7132320" y="2542032"/>
             <a:ext cx="1645920" cy="256032"/>
           </a:xfrm>
           <a:prstGeom prst="rect">
@@ -11178,7 +11178,7 @@
         </p:nvSpPr>
         <p:spPr>
           <a:xfrm>
-            <a:off x="365760" y="2843784"/>
+            <a:off x="365760" y="2916936"/>
             <a:ext cx="8412480" cy="347472"/>
           </a:xfrm>
           <a:prstGeom prst="rect">
@@ -11203,7 +11203,7 @@
         </p:nvSpPr>
         <p:spPr>
           <a:xfrm>
-            <a:off x="365760" y="2889504"/>
+            <a:off x="365760" y="2962656"/>
             <a:ext cx="2743200" cy="256032"/>
           </a:xfrm>
           <a:prstGeom prst="rect">
@@ -11242,7 +11242,7 @@
         </p:nvSpPr>
         <p:spPr>
           <a:xfrm>
-            <a:off x="3200400" y="2889504"/>
+            <a:off x="3200400" y="2962656"/>
             <a:ext cx="1645920" cy="256032"/>
           </a:xfrm>
           <a:prstGeom prst="rect">
@@ -11281,7 +11281,7 @@
         </p:nvSpPr>
         <p:spPr>
           <a:xfrm>
-            <a:off x="5029200" y="2889504"/>
+            <a:off x="5029200" y="2962656"/>
             <a:ext cx="1645920" cy="256032"/>
           </a:xfrm>
           <a:prstGeom prst="rect">
@@ -11320,7 +11320,7 @@
         </p:nvSpPr>
         <p:spPr>
           <a:xfrm>
-            <a:off x="7132320" y="2889504"/>
+            <a:off x="7132320" y="2962656"/>
             <a:ext cx="1645920" cy="256032"/>
           </a:xfrm>
           <a:prstGeom prst="rect">
@@ -11359,7 +11359,7 @@
         </p:nvSpPr>
         <p:spPr>
           <a:xfrm>
-            <a:off x="365760" y="3227832"/>
+            <a:off x="365760" y="3337560"/>
             <a:ext cx="8412480" cy="347472"/>
           </a:xfrm>
           <a:prstGeom prst="rect">
@@ -11384,7 +11384,7 @@
         </p:nvSpPr>
         <p:spPr>
           <a:xfrm>
-            <a:off x="365760" y="3273552"/>
+            <a:off x="365760" y="3383280"/>
             <a:ext cx="2743200" cy="256032"/>
           </a:xfrm>
           <a:prstGeom prst="rect">
@@ -11423,7 +11423,7 @@
         </p:nvSpPr>
         <p:spPr>
           <a:xfrm>
-            <a:off x="3200400" y="3273552"/>
+            <a:off x="3200400" y="3383280"/>
             <a:ext cx="1645920" cy="256032"/>
           </a:xfrm>
           <a:prstGeom prst="rect">
@@ -11462,7 +11462,7 @@
         </p:nvSpPr>
         <p:spPr>
           <a:xfrm>
-            <a:off x="5029200" y="3273552"/>
+            <a:off x="5029200" y="3383280"/>
             <a:ext cx="1645920" cy="256032"/>
           </a:xfrm>
           <a:prstGeom prst="rect">
@@ -11501,7 +11501,7 @@
         </p:nvSpPr>
         <p:spPr>
           <a:xfrm>
-            <a:off x="7132320" y="3273552"/>
+            <a:off x="7132320" y="3383280"/>
             <a:ext cx="1645920" cy="256032"/>
           </a:xfrm>
           <a:prstGeom prst="rect">
@@ -11540,7 +11540,7 @@
         </p:nvSpPr>
         <p:spPr>
           <a:xfrm>
-            <a:off x="365760" y="3611880"/>
+            <a:off x="365760" y="3758184"/>
             <a:ext cx="8412480" cy="347472"/>
           </a:xfrm>
           <a:prstGeom prst="rect">
@@ -11565,7 +11565,7 @@
         </p:nvSpPr>
         <p:spPr>
           <a:xfrm>
-            <a:off x="365760" y="3657600"/>
+            <a:off x="365760" y="3803904"/>
             <a:ext cx="2743200" cy="256032"/>
           </a:xfrm>
           <a:prstGeom prst="rect">
@@ -11604,7 +11604,7 @@
         </p:nvSpPr>
         <p:spPr>
           <a:xfrm>
-            <a:off x="3200400" y="3657600"/>
+            <a:off x="3200400" y="3803904"/>
             <a:ext cx="1645920" cy="256032"/>
           </a:xfrm>
           <a:prstGeom prst="rect">
@@ -11643,7 +11643,7 @@
         </p:nvSpPr>
         <p:spPr>
           <a:xfrm>
-            <a:off x="5029200" y="3657600"/>
+            <a:off x="5029200" y="3803904"/>
             <a:ext cx="1645920" cy="256032"/>
           </a:xfrm>
           <a:prstGeom prst="rect">
@@ -11682,7 +11682,7 @@
         </p:nvSpPr>
         <p:spPr>
           <a:xfrm>
-            <a:off x="7132320" y="3657600"/>
+            <a:off x="7132320" y="3803904"/>
             <a:ext cx="1645920" cy="256032"/>
           </a:xfrm>
           <a:prstGeom prst="rect">
@@ -11721,7 +11721,7 @@
         </p:nvSpPr>
         <p:spPr>
           <a:xfrm>
-            <a:off x="365760" y="3995928"/>
+            <a:off x="365760" y="4178808"/>
             <a:ext cx="8412480" cy="347472"/>
           </a:xfrm>
           <a:prstGeom prst="rect">
@@ -11746,7 +11746,7 @@
         </p:nvSpPr>
         <p:spPr>
           <a:xfrm>
-            <a:off x="365760" y="4041648"/>
+            <a:off x="365760" y="4224528"/>
             <a:ext cx="2743200" cy="256032"/>
           </a:xfrm>
           <a:prstGeom prst="rect">
@@ -11785,7 +11785,7 @@
         </p:nvSpPr>
         <p:spPr>
           <a:xfrm>
-            <a:off x="3200400" y="4041648"/>
+            <a:off x="3200400" y="4224528"/>
             <a:ext cx="1645920" cy="256032"/>
           </a:xfrm>
           <a:prstGeom prst="rect">
@@ -11824,7 +11824,7 @@
         </p:nvSpPr>
         <p:spPr>
           <a:xfrm>
-            <a:off x="5029200" y="4041648"/>
+            <a:off x="5029200" y="4224528"/>
             <a:ext cx="1645920" cy="256032"/>
           </a:xfrm>
           <a:prstGeom prst="rect">
@@ -11863,7 +11863,7 @@
         </p:nvSpPr>
         <p:spPr>
           <a:xfrm>
-            <a:off x="7132320" y="4041648"/>
+            <a:off x="7132320" y="4224528"/>
             <a:ext cx="1645920" cy="256032"/>
           </a:xfrm>
           <a:prstGeom prst="rect">

</xml_diff>

<commit_message>
docs: aggiungi slide risultati SI e SS alla presentazione EN + checkpoint 25-03-26
- Slide 11: baseline soggetto-indipendente (6 modelli × no_norm/norm, tutti a chance ~25%)
- Slide 12: baseline soggetto-specifica (26 soggetti, val 27-30% > chance, overfitting inter-sessione)
- Checkpoint 25-03-26: riepilogo risultati EEG_05 e EEG_06

Co-Authored-By: Claude Sonnet 4.6 <noreply@anthropic.com>
</commit_message>
<xml_diff>
--- a/docs/presentations/EN_EEG_Project_Status_Mar2026.pptx
+++ b/docs/presentations/EN_EEG_Project_Status_Mar2026.pptx
@@ -15,9 +15,11 @@
     <p:sldId id="263" r:id="rId9"/>
     <p:sldId id="264" r:id="rId10"/>
     <p:sldId id="265" r:id="rId11"/>
+    <p:sldId id="266" r:id="rId12"/>
+    <p:sldId id="267" r:id="rId13"/>
   </p:sldIdLst>
   <p:notesMasterIdLst>
-    <p:notesMasterId r:id="rId12"/>
+    <p:notesMasterId r:id="rId14"/>
   </p:notesMasterIdLst>
   <p:sldSz cx="9144000" cy="5143500"/>
   <p:notesSz cx="5143500" cy="9144000"/>
@@ -623,6 +625,182 @@
             <a:fld id="{F7021451-1387-4CA6-816F-3879F97B5CBC}" type="slidenum">
               <a:rPr lang="en-US"/>
               <a:t>10</a:t>
+            </a:fld>
+            <a:endParaRPr lang="en-US"/>
+          </a:p>
+        </p:txBody>
+      </p:sp>
+    </p:spTree>
+    <p:extLst>
+      <p:ext uri="{BB962C8B-B14F-4D97-AF65-F5344CB8AC3E}">
+        <p14:creationId xmlns:p14="http://schemas.microsoft.com/office/powerpoint/2010/main" val="1024086991"/>
+      </p:ext>
+    </p:extLst>
+  </p:cSld>
+  <p:clrMapOvr>
+    <a:masterClrMapping/>
+  </p:clrMapOvr>
+</p:notes>
+</file>
+
+<file path=ppt/notesSlides/notesSlide11.xml><?xml version="1.0" encoding="utf-8"?>
+<p:notes xmlns:a="http://schemas.openxmlformats.org/drawingml/2006/main" xmlns:r="http://schemas.openxmlformats.org/officeDocument/2006/relationships" xmlns:p="http://schemas.openxmlformats.org/presentationml/2006/main">
+  <p:cSld>
+    <p:spTree>
+      <p:nvGrpSpPr>
+        <p:cNvPr id="1" name=""/>
+        <p:cNvGrpSpPr/>
+        <p:nvPr/>
+      </p:nvGrpSpPr>
+      <p:grpSpPr>
+        <a:xfrm>
+          <a:off x="0" y="0"/>
+          <a:ext cx="0" cy="0"/>
+          <a:chOff x="0" y="0"/>
+          <a:chExt cx="0" cy="0"/>
+        </a:xfrm>
+      </p:grpSpPr>
+      <p:sp>
+        <p:nvSpPr>
+          <p:cNvPr id="2" name="Slide Image Placeholder 1"/>
+          <p:cNvSpPr>
+            <a:spLocks noGrp="1" noRot="1" noChangeAspect="1"/>
+          </p:cNvSpPr>
+          <p:nvPr>
+            <p:ph type="sldImg"/>
+          </p:nvPr>
+        </p:nvSpPr>
+        <p:spPr/>
+      </p:sp>
+      <p:sp>
+        <p:nvSpPr>
+          <p:cNvPr id="3" name="Notes Placeholder 2"/>
+          <p:cNvSpPr>
+            <a:spLocks noGrp="1"/>
+          </p:cNvSpPr>
+          <p:nvPr>
+            <p:ph type="body" idx="1"/>
+          </p:nvPr>
+        </p:nvSpPr>
+        <p:spPr/>
+        <p:txBody>
+          <a:bodyPr/>
+          <a:lstStyle/>
+          <a:p>
+            <a:r>
+              <a:rPr lang="en-US" dirty="0"/>
+              <a:t/>
+            </a:r>
+            <a:endParaRPr lang="en-US" dirty="0"/>
+          </a:p>
+        </p:txBody>
+      </p:sp>
+      <p:sp>
+        <p:nvSpPr>
+          <p:cNvPr id="4" name="Slide Number Placeholder 3"/>
+          <p:cNvSpPr>
+            <a:spLocks noGrp="1"/>
+          </p:cNvSpPr>
+          <p:nvPr>
+            <p:ph type="sldNum" sz="quarter" idx="10"/>
+          </p:nvPr>
+        </p:nvSpPr>
+        <p:spPr/>
+        <p:txBody>
+          <a:bodyPr/>
+          <a:lstStyle/>
+          <a:p>
+            <a:fld id="{F7021451-1387-4CA6-816F-3879F97B5CBC}" type="slidenum">
+              <a:rPr lang="en-US"/>
+              <a:t>11</a:t>
+            </a:fld>
+            <a:endParaRPr lang="en-US"/>
+          </a:p>
+        </p:txBody>
+      </p:sp>
+    </p:spTree>
+    <p:extLst>
+      <p:ext uri="{BB962C8B-B14F-4D97-AF65-F5344CB8AC3E}">
+        <p14:creationId xmlns:p14="http://schemas.microsoft.com/office/powerpoint/2010/main" val="1024086991"/>
+      </p:ext>
+    </p:extLst>
+  </p:cSld>
+  <p:clrMapOvr>
+    <a:masterClrMapping/>
+  </p:clrMapOvr>
+</p:notes>
+</file>
+
+<file path=ppt/notesSlides/notesSlide12.xml><?xml version="1.0" encoding="utf-8"?>
+<p:notes xmlns:a="http://schemas.openxmlformats.org/drawingml/2006/main" xmlns:r="http://schemas.openxmlformats.org/officeDocument/2006/relationships" xmlns:p="http://schemas.openxmlformats.org/presentationml/2006/main">
+  <p:cSld>
+    <p:spTree>
+      <p:nvGrpSpPr>
+        <p:cNvPr id="1" name=""/>
+        <p:cNvGrpSpPr/>
+        <p:nvPr/>
+      </p:nvGrpSpPr>
+      <p:grpSpPr>
+        <a:xfrm>
+          <a:off x="0" y="0"/>
+          <a:ext cx="0" cy="0"/>
+          <a:chOff x="0" y="0"/>
+          <a:chExt cx="0" cy="0"/>
+        </a:xfrm>
+      </p:grpSpPr>
+      <p:sp>
+        <p:nvSpPr>
+          <p:cNvPr id="2" name="Slide Image Placeholder 1"/>
+          <p:cNvSpPr>
+            <a:spLocks noGrp="1" noRot="1" noChangeAspect="1"/>
+          </p:cNvSpPr>
+          <p:nvPr>
+            <p:ph type="sldImg"/>
+          </p:nvPr>
+        </p:nvSpPr>
+        <p:spPr/>
+      </p:sp>
+      <p:sp>
+        <p:nvSpPr>
+          <p:cNvPr id="3" name="Notes Placeholder 2"/>
+          <p:cNvSpPr>
+            <a:spLocks noGrp="1"/>
+          </p:cNvSpPr>
+          <p:nvPr>
+            <p:ph type="body" idx="1"/>
+          </p:nvPr>
+        </p:nvSpPr>
+        <p:spPr/>
+        <p:txBody>
+          <a:bodyPr/>
+          <a:lstStyle/>
+          <a:p>
+            <a:r>
+              <a:rPr lang="en-US" dirty="0"/>
+              <a:t/>
+            </a:r>
+            <a:endParaRPr lang="en-US" dirty="0"/>
+          </a:p>
+        </p:txBody>
+      </p:sp>
+      <p:sp>
+        <p:nvSpPr>
+          <p:cNvPr id="4" name="Slide Number Placeholder 3"/>
+          <p:cNvSpPr>
+            <a:spLocks noGrp="1"/>
+          </p:cNvSpPr>
+          <p:nvPr>
+            <p:ph type="sldNum" sz="quarter" idx="10"/>
+          </p:nvPr>
+        </p:nvSpPr>
+        <p:spPr/>
+        <p:txBody>
+          <a:bodyPr/>
+          <a:lstStyle/>
+          <a:p>
+            <a:fld id="{F7021451-1387-4CA6-816F-3879F97B5CBC}" type="slidenum">
+              <a:rPr lang="en-US"/>
+              <a:t>12</a:t>
             </a:fld>
             <a:endParaRPr lang="en-US"/>
           </a:p>
@@ -2853,6 +3031,3858 @@
 </p:sld>
 </file>
 
+<file path=ppt/slides/slide11.xml><?xml version="1.0" encoding="utf-8"?>
+<p:sld xmlns:a="http://schemas.openxmlformats.org/drawingml/2006/main" xmlns:r="http://schemas.openxmlformats.org/officeDocument/2006/relationships" xmlns:p="http://schemas.openxmlformats.org/presentationml/2006/main">
+  <p:cSld name="Slide 11">
+    <p:bg>
+      <p:bgPr>
+        <a:solidFill>
+          <a:srgbClr val="FFFFFF"/>
+        </a:solidFill>
+      </p:bgPr>
+    </p:bg>
+    <p:spTree>
+      <p:nvGrpSpPr>
+        <p:cNvPr id="1" name=""/>
+        <p:cNvGrpSpPr/>
+        <p:nvPr/>
+      </p:nvGrpSpPr>
+      <p:grpSpPr>
+        <a:xfrm>
+          <a:off x="0" y="0"/>
+          <a:ext cx="0" cy="0"/>
+          <a:chOff x="0" y="0"/>
+          <a:chExt cx="0" cy="0"/>
+        </a:xfrm>
+      </p:grpSpPr>
+      <p:sp>
+        <p:nvSpPr>
+          <p:cNvPr id="2" name="Shape 0"/>
+          <p:cNvSpPr/>
+          <p:nvPr/>
+        </p:nvSpPr>
+        <p:spPr>
+          <a:xfrm>
+            <a:off x="0" y="0"/>
+            <a:ext cx="9144000" cy="73152"/>
+          </a:xfrm>
+          <a:prstGeom prst="rect">
+            <a:avLst/>
+          </a:prstGeom>
+          <a:solidFill>
+            <a:srgbClr val="00B4D8"/>
+          </a:solidFill>
+          <a:ln w="12700">
+            <a:solidFill>
+              <a:srgbClr val="00B4D8"/>
+            </a:solidFill>
+            <a:prstDash val="solid"/>
+          </a:ln>
+        </p:spPr>
+      </p:sp>
+      <p:sp>
+        <p:nvSpPr>
+          <p:cNvPr id="3" name="Text 1"/>
+          <p:cNvSpPr/>
+          <p:nvPr/>
+        </p:nvSpPr>
+        <p:spPr>
+          <a:xfrm>
+            <a:off x="365760" y="164592"/>
+            <a:ext cx="8412480" cy="502920"/>
+          </a:xfrm>
+          <a:prstGeom prst="rect">
+            <a:avLst/>
+          </a:prstGeom>
+          <a:noFill/>
+          <a:ln/>
+        </p:spPr>
+        <p:txBody>
+          <a:bodyPr wrap="square" lIns="0" tIns="0" rIns="0" bIns="0" rtlCol="0" anchor="ctr"/>
+          <a:lstStyle/>
+          <a:p>
+            <a:pPr indent="0" marL="0">
+              <a:buNone/>
+            </a:pPr>
+            <a:r>
+              <a:rPr lang="en-US" sz="2600" b="1" dirty="0">
+                <a:solidFill>
+                  <a:srgbClr val="1A2A4A"/>
+                </a:solidFill>
+                <a:latin typeface="Calibri" pitchFamily="34" charset="0"/>
+                <a:ea typeface="Calibri" pitchFamily="34" charset="-122"/>
+                <a:cs typeface="Calibri" pitchFamily="34" charset="-120"/>
+              </a:rPr>
+              <a:t>Subject-Independent Baseline Results</a:t>
+            </a:r>
+            <a:endParaRPr lang="en-US" sz="2600" dirty="0"/>
+          </a:p>
+        </p:txBody>
+      </p:sp>
+      <p:sp>
+        <p:nvSpPr>
+          <p:cNvPr id="4" name="Text 2"/>
+          <p:cNvSpPr/>
+          <p:nvPr/>
+        </p:nvSpPr>
+        <p:spPr>
+          <a:xfrm>
+            <a:off x="365760" y="658368"/>
+            <a:ext cx="8412480" cy="274320"/>
+          </a:xfrm>
+          <a:prstGeom prst="rect">
+            <a:avLst/>
+          </a:prstGeom>
+          <a:noFill/>
+          <a:ln/>
+        </p:spPr>
+        <p:txBody>
+          <a:bodyPr wrap="square" lIns="0" tIns="0" rIns="0" bIns="0" rtlCol="0" anchor="ctr"/>
+          <a:lstStyle/>
+          <a:p>
+            <a:pPr indent="0" marL="0">
+              <a:buNone/>
+            </a:pPr>
+            <a:r>
+              <a:rPr lang="en-US" sz="1300" dirty="0">
+                <a:solidFill>
+                  <a:srgbClr val="6B7A99"/>
+                </a:solidFill>
+                <a:latin typeface="Calibri" pitchFamily="34" charset="0"/>
+                <a:ea typeface="Calibri" pitchFamily="34" charset="-122"/>
+                <a:cs typeface="Calibri" pitchFamily="34" charset="-120"/>
+              </a:rPr>
+              <a:t>Train: subjects 01–50  |  Val: 51–60  |  Test: 61–74  |  4 classes (concr4)  |  Chance = 25%</a:t>
+            </a:r>
+            <a:endParaRPr lang="en-US" sz="1300" dirty="0"/>
+          </a:p>
+        </p:txBody>
+      </p:sp>
+      <p:sp>
+        <p:nvSpPr>
+          <p:cNvPr id="5" name="Shape 3"/>
+          <p:cNvSpPr/>
+          <p:nvPr/>
+        </p:nvSpPr>
+        <p:spPr>
+          <a:xfrm>
+            <a:off x="365760" y="960120"/>
+            <a:ext cx="8412480" cy="0"/>
+          </a:xfrm>
+          <a:prstGeom prst="line">
+            <a:avLst/>
+          </a:prstGeom>
+          <a:noFill/>
+          <a:ln w="19050">
+            <a:solidFill>
+              <a:srgbClr val="00B4D8"/>
+            </a:solidFill>
+            <a:prstDash val="solid"/>
+          </a:ln>
+        </p:spPr>
+      </p:sp>
+      <p:sp>
+        <p:nvSpPr>
+          <p:cNvPr id="6" name="Shape 4"/>
+          <p:cNvSpPr/>
+          <p:nvPr/>
+        </p:nvSpPr>
+        <p:spPr>
+          <a:xfrm>
+            <a:off x="822960" y="3566160"/>
+            <a:ext cx="6858000" cy="0"/>
+          </a:xfrm>
+          <a:prstGeom prst="line">
+            <a:avLst/>
+          </a:prstGeom>
+          <a:noFill/>
+          <a:ln w="12700">
+            <a:solidFill>
+              <a:srgbClr val="6B7A99"/>
+            </a:solidFill>
+            <a:prstDash val="solid"/>
+          </a:ln>
+        </p:spPr>
+      </p:sp>
+      <p:sp>
+        <p:nvSpPr>
+          <p:cNvPr id="7" name="Text 5"/>
+          <p:cNvSpPr/>
+          <p:nvPr/>
+        </p:nvSpPr>
+        <p:spPr>
+          <a:xfrm>
+            <a:off x="228600" y="3447288"/>
+            <a:ext cx="566928" cy="237744"/>
+          </a:xfrm>
+          <a:prstGeom prst="rect">
+            <a:avLst/>
+          </a:prstGeom>
+          <a:noFill/>
+          <a:ln/>
+        </p:spPr>
+        <p:txBody>
+          <a:bodyPr wrap="square" lIns="0" tIns="0" rIns="0" bIns="0" rtlCol="0" anchor="ctr"/>
+          <a:lstStyle/>
+          <a:p>
+            <a:pPr algn="r" indent="0" marL="0">
+              <a:buNone/>
+            </a:pPr>
+            <a:r>
+              <a:rPr lang="en-US" sz="800" dirty="0">
+                <a:solidFill>
+                  <a:srgbClr val="6B7A99"/>
+                </a:solidFill>
+                <a:latin typeface="Calibri" pitchFamily="34" charset="0"/>
+                <a:ea typeface="Calibri" pitchFamily="34" charset="-122"/>
+                <a:cs typeface="Calibri" pitchFamily="34" charset="-120"/>
+              </a:rPr>
+              <a:t>23.5%</a:t>
+            </a:r>
+            <a:endParaRPr lang="en-US" sz="800" dirty="0"/>
+          </a:p>
+        </p:txBody>
+      </p:sp>
+      <p:sp>
+        <p:nvSpPr>
+          <p:cNvPr id="8" name="Shape 6"/>
+          <p:cNvSpPr/>
+          <p:nvPr/>
+        </p:nvSpPr>
+        <p:spPr>
+          <a:xfrm>
+            <a:off x="822960" y="3081528"/>
+            <a:ext cx="6858000" cy="0"/>
+          </a:xfrm>
+          <a:prstGeom prst="line">
+            <a:avLst/>
+          </a:prstGeom>
+          <a:noFill/>
+          <a:ln w="6350">
+            <a:solidFill>
+              <a:srgbClr val="DDDDDD"/>
+            </a:solidFill>
+            <a:prstDash val="sysDot"/>
+          </a:ln>
+        </p:spPr>
+      </p:sp>
+      <p:sp>
+        <p:nvSpPr>
+          <p:cNvPr id="9" name="Text 7"/>
+          <p:cNvSpPr/>
+          <p:nvPr/>
+        </p:nvSpPr>
+        <p:spPr>
+          <a:xfrm>
+            <a:off x="228600" y="2962656"/>
+            <a:ext cx="566928" cy="237744"/>
+          </a:xfrm>
+          <a:prstGeom prst="rect">
+            <a:avLst/>
+          </a:prstGeom>
+          <a:noFill/>
+          <a:ln/>
+        </p:spPr>
+        <p:txBody>
+          <a:bodyPr wrap="square" lIns="0" tIns="0" rIns="0" bIns="0" rtlCol="0" anchor="ctr"/>
+          <a:lstStyle/>
+          <a:p>
+            <a:pPr algn="r" indent="0" marL="0">
+              <a:buNone/>
+            </a:pPr>
+            <a:r>
+              <a:rPr lang="en-US" sz="800" dirty="0">
+                <a:solidFill>
+                  <a:srgbClr val="6B7A99"/>
+                </a:solidFill>
+                <a:latin typeface="Calibri" pitchFamily="34" charset="0"/>
+                <a:ea typeface="Calibri" pitchFamily="34" charset="-122"/>
+                <a:cs typeface="Calibri" pitchFamily="34" charset="-120"/>
+              </a:rPr>
+              <a:t>24.0%</a:t>
+            </a:r>
+            <a:endParaRPr lang="en-US" sz="800" dirty="0"/>
+          </a:p>
+        </p:txBody>
+      </p:sp>
+      <p:sp>
+        <p:nvSpPr>
+          <p:cNvPr id="10" name="Shape 8"/>
+          <p:cNvSpPr/>
+          <p:nvPr/>
+        </p:nvSpPr>
+        <p:spPr>
+          <a:xfrm>
+            <a:off x="822960" y="2596896"/>
+            <a:ext cx="6858000" cy="0"/>
+          </a:xfrm>
+          <a:prstGeom prst="line">
+            <a:avLst/>
+          </a:prstGeom>
+          <a:noFill/>
+          <a:ln w="6350">
+            <a:solidFill>
+              <a:srgbClr val="DDDDDD"/>
+            </a:solidFill>
+            <a:prstDash val="sysDot"/>
+          </a:ln>
+        </p:spPr>
+      </p:sp>
+      <p:sp>
+        <p:nvSpPr>
+          <p:cNvPr id="11" name="Text 9"/>
+          <p:cNvSpPr/>
+          <p:nvPr/>
+        </p:nvSpPr>
+        <p:spPr>
+          <a:xfrm>
+            <a:off x="228600" y="2478024"/>
+            <a:ext cx="566928" cy="237744"/>
+          </a:xfrm>
+          <a:prstGeom prst="rect">
+            <a:avLst/>
+          </a:prstGeom>
+          <a:noFill/>
+          <a:ln/>
+        </p:spPr>
+        <p:txBody>
+          <a:bodyPr wrap="square" lIns="0" tIns="0" rIns="0" bIns="0" rtlCol="0" anchor="ctr"/>
+          <a:lstStyle/>
+          <a:p>
+            <a:pPr algn="r" indent="0" marL="0">
+              <a:buNone/>
+            </a:pPr>
+            <a:r>
+              <a:rPr lang="en-US" sz="800" dirty="0">
+                <a:solidFill>
+                  <a:srgbClr val="6B7A99"/>
+                </a:solidFill>
+                <a:latin typeface="Calibri" pitchFamily="34" charset="0"/>
+                <a:ea typeface="Calibri" pitchFamily="34" charset="-122"/>
+                <a:cs typeface="Calibri" pitchFamily="34" charset="-120"/>
+              </a:rPr>
+              <a:t>24.5%</a:t>
+            </a:r>
+            <a:endParaRPr lang="en-US" sz="800" dirty="0"/>
+          </a:p>
+        </p:txBody>
+      </p:sp>
+      <p:sp>
+        <p:nvSpPr>
+          <p:cNvPr id="12" name="Shape 10"/>
+          <p:cNvSpPr/>
+          <p:nvPr/>
+        </p:nvSpPr>
+        <p:spPr>
+          <a:xfrm>
+            <a:off x="822960" y="2112264"/>
+            <a:ext cx="6858000" cy="0"/>
+          </a:xfrm>
+          <a:prstGeom prst="line">
+            <a:avLst/>
+          </a:prstGeom>
+          <a:noFill/>
+          <a:ln w="6350">
+            <a:solidFill>
+              <a:srgbClr val="DDDDDD"/>
+            </a:solidFill>
+            <a:prstDash val="sysDot"/>
+          </a:ln>
+        </p:spPr>
+      </p:sp>
+      <p:sp>
+        <p:nvSpPr>
+          <p:cNvPr id="13" name="Text 11"/>
+          <p:cNvSpPr/>
+          <p:nvPr/>
+        </p:nvSpPr>
+        <p:spPr>
+          <a:xfrm>
+            <a:off x="228600" y="1993392"/>
+            <a:ext cx="566928" cy="237744"/>
+          </a:xfrm>
+          <a:prstGeom prst="rect">
+            <a:avLst/>
+          </a:prstGeom>
+          <a:noFill/>
+          <a:ln/>
+        </p:spPr>
+        <p:txBody>
+          <a:bodyPr wrap="square" lIns="0" tIns="0" rIns="0" bIns="0" rtlCol="0" anchor="ctr"/>
+          <a:lstStyle/>
+          <a:p>
+            <a:pPr algn="r" indent="0" marL="0">
+              <a:buNone/>
+            </a:pPr>
+            <a:r>
+              <a:rPr lang="en-US" sz="800" dirty="0">
+                <a:solidFill>
+                  <a:srgbClr val="6B7A99"/>
+                </a:solidFill>
+                <a:latin typeface="Calibri" pitchFamily="34" charset="0"/>
+                <a:ea typeface="Calibri" pitchFamily="34" charset="-122"/>
+                <a:cs typeface="Calibri" pitchFamily="34" charset="-120"/>
+              </a:rPr>
+              <a:t>25.0%</a:t>
+            </a:r>
+            <a:endParaRPr lang="en-US" sz="800" dirty="0"/>
+          </a:p>
+        </p:txBody>
+      </p:sp>
+      <p:sp>
+        <p:nvSpPr>
+          <p:cNvPr id="14" name="Shape 12"/>
+          <p:cNvSpPr/>
+          <p:nvPr/>
+        </p:nvSpPr>
+        <p:spPr>
+          <a:xfrm>
+            <a:off x="822960" y="1627632"/>
+            <a:ext cx="6858000" cy="0"/>
+          </a:xfrm>
+          <a:prstGeom prst="line">
+            <a:avLst/>
+          </a:prstGeom>
+          <a:noFill/>
+          <a:ln w="6350">
+            <a:solidFill>
+              <a:srgbClr val="DDDDDD"/>
+            </a:solidFill>
+            <a:prstDash val="sysDot"/>
+          </a:ln>
+        </p:spPr>
+      </p:sp>
+      <p:sp>
+        <p:nvSpPr>
+          <p:cNvPr id="15" name="Text 13"/>
+          <p:cNvSpPr/>
+          <p:nvPr/>
+        </p:nvSpPr>
+        <p:spPr>
+          <a:xfrm>
+            <a:off x="228600" y="1508760"/>
+            <a:ext cx="566928" cy="237744"/>
+          </a:xfrm>
+          <a:prstGeom prst="rect">
+            <a:avLst/>
+          </a:prstGeom>
+          <a:noFill/>
+          <a:ln/>
+        </p:spPr>
+        <p:txBody>
+          <a:bodyPr wrap="square" lIns="0" tIns="0" rIns="0" bIns="0" rtlCol="0" anchor="ctr"/>
+          <a:lstStyle/>
+          <a:p>
+            <a:pPr algn="r" indent="0" marL="0">
+              <a:buNone/>
+            </a:pPr>
+            <a:r>
+              <a:rPr lang="en-US" sz="800" dirty="0">
+                <a:solidFill>
+                  <a:srgbClr val="6B7A99"/>
+                </a:solidFill>
+                <a:latin typeface="Calibri" pitchFamily="34" charset="0"/>
+                <a:ea typeface="Calibri" pitchFamily="34" charset="-122"/>
+                <a:cs typeface="Calibri" pitchFamily="34" charset="-120"/>
+              </a:rPr>
+              <a:t>25.5%</a:t>
+            </a:r>
+            <a:endParaRPr lang="en-US" sz="800" dirty="0"/>
+          </a:p>
+        </p:txBody>
+      </p:sp>
+      <p:sp>
+        <p:nvSpPr>
+          <p:cNvPr id="16" name="Shape 14"/>
+          <p:cNvSpPr/>
+          <p:nvPr/>
+        </p:nvSpPr>
+        <p:spPr>
+          <a:xfrm>
+            <a:off x="822960" y="1143000"/>
+            <a:ext cx="6858000" cy="0"/>
+          </a:xfrm>
+          <a:prstGeom prst="line">
+            <a:avLst/>
+          </a:prstGeom>
+          <a:noFill/>
+          <a:ln w="6350">
+            <a:solidFill>
+              <a:srgbClr val="DDDDDD"/>
+            </a:solidFill>
+            <a:prstDash val="sysDot"/>
+          </a:ln>
+        </p:spPr>
+      </p:sp>
+      <p:sp>
+        <p:nvSpPr>
+          <p:cNvPr id="17" name="Text 15"/>
+          <p:cNvSpPr/>
+          <p:nvPr/>
+        </p:nvSpPr>
+        <p:spPr>
+          <a:xfrm>
+            <a:off x="228600" y="1024128"/>
+            <a:ext cx="566928" cy="237744"/>
+          </a:xfrm>
+          <a:prstGeom prst="rect">
+            <a:avLst/>
+          </a:prstGeom>
+          <a:noFill/>
+          <a:ln/>
+        </p:spPr>
+        <p:txBody>
+          <a:bodyPr wrap="square" lIns="0" tIns="0" rIns="0" bIns="0" rtlCol="0" anchor="ctr"/>
+          <a:lstStyle/>
+          <a:p>
+            <a:pPr algn="r" indent="0" marL="0">
+              <a:buNone/>
+            </a:pPr>
+            <a:r>
+              <a:rPr lang="en-US" sz="800" dirty="0">
+                <a:solidFill>
+                  <a:srgbClr val="6B7A99"/>
+                </a:solidFill>
+                <a:latin typeface="Calibri" pitchFamily="34" charset="0"/>
+                <a:ea typeface="Calibri" pitchFamily="34" charset="-122"/>
+                <a:cs typeface="Calibri" pitchFamily="34" charset="-120"/>
+              </a:rPr>
+              <a:t>26.0%</a:t>
+            </a:r>
+            <a:endParaRPr lang="en-US" sz="800" dirty="0"/>
+          </a:p>
+        </p:txBody>
+      </p:sp>
+      <p:sp>
+        <p:nvSpPr>
+          <p:cNvPr id="18" name="Shape 16"/>
+          <p:cNvSpPr/>
+          <p:nvPr/>
+        </p:nvSpPr>
+        <p:spPr>
+          <a:xfrm>
+            <a:off x="822960" y="2112264"/>
+            <a:ext cx="6858000" cy="0"/>
+          </a:xfrm>
+          <a:prstGeom prst="line">
+            <a:avLst/>
+          </a:prstGeom>
+          <a:noFill/>
+          <a:ln w="19050">
+            <a:solidFill>
+              <a:srgbClr val="E63946"/>
+            </a:solidFill>
+            <a:prstDash val="dash"/>
+          </a:ln>
+        </p:spPr>
+      </p:sp>
+      <p:sp>
+        <p:nvSpPr>
+          <p:cNvPr id="19" name="Text 17"/>
+          <p:cNvSpPr/>
+          <p:nvPr/>
+        </p:nvSpPr>
+        <p:spPr>
+          <a:xfrm>
+            <a:off x="7726680" y="1984248"/>
+            <a:ext cx="1188720" cy="256032"/>
+          </a:xfrm>
+          <a:prstGeom prst="rect">
+            <a:avLst/>
+          </a:prstGeom>
+          <a:noFill/>
+          <a:ln/>
+        </p:spPr>
+        <p:txBody>
+          <a:bodyPr wrap="square" lIns="0" tIns="0" rIns="0" bIns="0" rtlCol="0" anchor="ctr"/>
+          <a:lstStyle/>
+          <a:p>
+            <a:pPr indent="0" marL="0">
+              <a:buNone/>
+            </a:pPr>
+            <a:r>
+              <a:rPr lang="en-US" sz="800" b="1" dirty="0">
+                <a:solidFill>
+                  <a:srgbClr val="E63946"/>
+                </a:solidFill>
+                <a:latin typeface="Calibri" pitchFamily="34" charset="0"/>
+                <a:ea typeface="Calibri" pitchFamily="34" charset="-122"/>
+                <a:cs typeface="Calibri" pitchFamily="34" charset="-120"/>
+              </a:rPr>
+              <a:t>— 25% chance</a:t>
+            </a:r>
+            <a:endParaRPr lang="en-US" sz="800" dirty="0"/>
+          </a:p>
+        </p:txBody>
+      </p:sp>
+      <p:sp>
+        <p:nvSpPr>
+          <p:cNvPr id="20" name="Shape 18"/>
+          <p:cNvSpPr/>
+          <p:nvPr/>
+        </p:nvSpPr>
+        <p:spPr>
+          <a:xfrm>
+            <a:off x="822960" y="1143000"/>
+            <a:ext cx="0" cy="2423160"/>
+          </a:xfrm>
+          <a:prstGeom prst="line">
+            <a:avLst/>
+          </a:prstGeom>
+          <a:noFill/>
+          <a:ln w="12700">
+            <a:solidFill>
+              <a:srgbClr val="6B7A99"/>
+            </a:solidFill>
+            <a:prstDash val="solid"/>
+          </a:ln>
+        </p:spPr>
+      </p:sp>
+      <p:sp>
+        <p:nvSpPr>
+          <p:cNvPr id="21" name="Shape 19"/>
+          <p:cNvSpPr/>
+          <p:nvPr/>
+        </p:nvSpPr>
+        <p:spPr>
+          <a:xfrm>
+            <a:off x="1014984" y="2092879"/>
+            <a:ext cx="347472" cy="1473281"/>
+          </a:xfrm>
+          <a:prstGeom prst="rect">
+            <a:avLst/>
+          </a:prstGeom>
+          <a:solidFill>
+            <a:srgbClr val="1A2A4A"/>
+          </a:solidFill>
+          <a:ln w="12700">
+            <a:solidFill>
+              <a:srgbClr val="1A2A4A"/>
+            </a:solidFill>
+            <a:prstDash val="solid"/>
+          </a:ln>
+        </p:spPr>
+      </p:sp>
+      <p:sp>
+        <p:nvSpPr>
+          <p:cNvPr id="22" name="Text 20"/>
+          <p:cNvSpPr/>
+          <p:nvPr/>
+        </p:nvSpPr>
+        <p:spPr>
+          <a:xfrm>
+            <a:off x="969264" y="1928287"/>
+            <a:ext cx="438912" cy="155448"/>
+          </a:xfrm>
+          <a:prstGeom prst="rect">
+            <a:avLst/>
+          </a:prstGeom>
+          <a:noFill/>
+          <a:ln/>
+        </p:spPr>
+        <p:txBody>
+          <a:bodyPr wrap="square" lIns="0" tIns="0" rIns="0" bIns="0" rtlCol="0" anchor="ctr"/>
+          <a:lstStyle/>
+          <a:p>
+            <a:pPr algn="ctr" indent="0" marL="0">
+              <a:buNone/>
+            </a:pPr>
+            <a:r>
+              <a:rPr lang="en-US" sz="650" b="1" dirty="0">
+                <a:solidFill>
+                  <a:srgbClr val="1A2A4A"/>
+                </a:solidFill>
+                <a:latin typeface="Calibri" pitchFamily="34" charset="0"/>
+                <a:ea typeface="Calibri" pitchFamily="34" charset="-122"/>
+                <a:cs typeface="Calibri" pitchFamily="34" charset="-120"/>
+              </a:rPr>
+              <a:t>25.0%</a:t>
+            </a:r>
+            <a:endParaRPr lang="en-US" sz="650" dirty="0"/>
+          </a:p>
+        </p:txBody>
+      </p:sp>
+      <p:sp>
+        <p:nvSpPr>
+          <p:cNvPr id="23" name="Shape 21"/>
+          <p:cNvSpPr/>
+          <p:nvPr/>
+        </p:nvSpPr>
+        <p:spPr>
+          <a:xfrm>
+            <a:off x="1426464" y="2121957"/>
+            <a:ext cx="347472" cy="1444203"/>
+          </a:xfrm>
+          <a:prstGeom prst="rect">
+            <a:avLst/>
+          </a:prstGeom>
+          <a:solidFill>
+            <a:srgbClr val="00B4D8"/>
+          </a:solidFill>
+          <a:ln w="12700">
+            <a:solidFill>
+              <a:srgbClr val="00B4D8"/>
+            </a:solidFill>
+            <a:prstDash val="solid"/>
+          </a:ln>
+        </p:spPr>
+      </p:sp>
+      <p:sp>
+        <p:nvSpPr>
+          <p:cNvPr id="24" name="Text 22"/>
+          <p:cNvSpPr/>
+          <p:nvPr/>
+        </p:nvSpPr>
+        <p:spPr>
+          <a:xfrm>
+            <a:off x="1380744" y="1957365"/>
+            <a:ext cx="438912" cy="155448"/>
+          </a:xfrm>
+          <a:prstGeom prst="rect">
+            <a:avLst/>
+          </a:prstGeom>
+          <a:noFill/>
+          <a:ln/>
+        </p:spPr>
+        <p:txBody>
+          <a:bodyPr wrap="square" lIns="0" tIns="0" rIns="0" bIns="0" rtlCol="0" anchor="ctr"/>
+          <a:lstStyle/>
+          <a:p>
+            <a:pPr algn="ctr" indent="0" marL="0">
+              <a:buNone/>
+            </a:pPr>
+            <a:r>
+              <a:rPr lang="en-US" sz="650" b="1" dirty="0">
+                <a:solidFill>
+                  <a:srgbClr val="00B4D8"/>
+                </a:solidFill>
+                <a:latin typeface="Calibri" pitchFamily="34" charset="0"/>
+                <a:ea typeface="Calibri" pitchFamily="34" charset="-122"/>
+                <a:cs typeface="Calibri" pitchFamily="34" charset="-120"/>
+              </a:rPr>
+              <a:t>25.0%</a:t>
+            </a:r>
+            <a:endParaRPr lang="en-US" sz="650" dirty="0"/>
+          </a:p>
+        </p:txBody>
+      </p:sp>
+      <p:sp>
+        <p:nvSpPr>
+          <p:cNvPr id="25" name="Text 23"/>
+          <p:cNvSpPr/>
+          <p:nvPr/>
+        </p:nvSpPr>
+        <p:spPr>
+          <a:xfrm>
+            <a:off x="868680" y="3621024"/>
+            <a:ext cx="1051560" cy="347472"/>
+          </a:xfrm>
+          <a:prstGeom prst="rect">
+            <a:avLst/>
+          </a:prstGeom>
+          <a:noFill/>
+          <a:ln/>
+        </p:spPr>
+        <p:txBody>
+          <a:bodyPr wrap="square" lIns="0" tIns="0" rIns="0" bIns="0" rtlCol="0" anchor="ctr"/>
+          <a:lstStyle/>
+          <a:p>
+            <a:pPr algn="ctr" indent="0" marL="0">
+              <a:buNone/>
+            </a:pPr>
+            <a:r>
+              <a:rPr lang="en-US" sz="850" dirty="0">
+                <a:solidFill>
+                  <a:srgbClr val="0D1B2A"/>
+                </a:solidFill>
+                <a:latin typeface="Calibri" pitchFamily="34" charset="0"/>
+                <a:ea typeface="Calibri" pitchFamily="34" charset="-122"/>
+                <a:cs typeface="Calibri" pitchFamily="34" charset="-120"/>
+              </a:rPr>
+              <a:t>ATCNet</a:t>
+            </a:r>
+            <a:endParaRPr lang="en-US" sz="850" dirty="0"/>
+          </a:p>
+        </p:txBody>
+      </p:sp>
+      <p:sp>
+        <p:nvSpPr>
+          <p:cNvPr id="26" name="Shape 24"/>
+          <p:cNvSpPr/>
+          <p:nvPr/>
+        </p:nvSpPr>
+        <p:spPr>
+          <a:xfrm>
+            <a:off x="2157984" y="2199498"/>
+            <a:ext cx="347472" cy="1366662"/>
+          </a:xfrm>
+          <a:prstGeom prst="rect">
+            <a:avLst/>
+          </a:prstGeom>
+          <a:solidFill>
+            <a:srgbClr val="1A2A4A"/>
+          </a:solidFill>
+          <a:ln w="12700">
+            <a:solidFill>
+              <a:srgbClr val="1A2A4A"/>
+            </a:solidFill>
+            <a:prstDash val="solid"/>
+          </a:ln>
+        </p:spPr>
+      </p:sp>
+      <p:sp>
+        <p:nvSpPr>
+          <p:cNvPr id="27" name="Text 25"/>
+          <p:cNvSpPr/>
+          <p:nvPr/>
+        </p:nvSpPr>
+        <p:spPr>
+          <a:xfrm>
+            <a:off x="2112264" y="2034906"/>
+            <a:ext cx="438912" cy="155448"/>
+          </a:xfrm>
+          <a:prstGeom prst="rect">
+            <a:avLst/>
+          </a:prstGeom>
+          <a:noFill/>
+          <a:ln/>
+        </p:spPr>
+        <p:txBody>
+          <a:bodyPr wrap="square" lIns="0" tIns="0" rIns="0" bIns="0" rtlCol="0" anchor="ctr"/>
+          <a:lstStyle/>
+          <a:p>
+            <a:pPr algn="ctr" indent="0" marL="0">
+              <a:buNone/>
+            </a:pPr>
+            <a:r>
+              <a:rPr lang="en-US" sz="650" b="1" dirty="0">
+                <a:solidFill>
+                  <a:srgbClr val="1A2A4A"/>
+                </a:solidFill>
+                <a:latin typeface="Calibri" pitchFamily="34" charset="0"/>
+                <a:ea typeface="Calibri" pitchFamily="34" charset="-122"/>
+                <a:cs typeface="Calibri" pitchFamily="34" charset="-120"/>
+              </a:rPr>
+              <a:t>24.9%</a:t>
+            </a:r>
+            <a:endParaRPr lang="en-US" sz="650" dirty="0"/>
+          </a:p>
+        </p:txBody>
+      </p:sp>
+      <p:sp>
+        <p:nvSpPr>
+          <p:cNvPr id="28" name="Shape 26"/>
+          <p:cNvSpPr/>
+          <p:nvPr/>
+        </p:nvSpPr>
+        <p:spPr>
+          <a:xfrm>
+            <a:off x="2569464" y="1947489"/>
+            <a:ext cx="347472" cy="1618671"/>
+          </a:xfrm>
+          <a:prstGeom prst="rect">
+            <a:avLst/>
+          </a:prstGeom>
+          <a:solidFill>
+            <a:srgbClr val="00B4D8"/>
+          </a:solidFill>
+          <a:ln w="12700">
+            <a:solidFill>
+              <a:srgbClr val="00B4D8"/>
+            </a:solidFill>
+            <a:prstDash val="solid"/>
+          </a:ln>
+        </p:spPr>
+      </p:sp>
+      <p:sp>
+        <p:nvSpPr>
+          <p:cNvPr id="29" name="Text 27"/>
+          <p:cNvSpPr/>
+          <p:nvPr/>
+        </p:nvSpPr>
+        <p:spPr>
+          <a:xfrm>
+            <a:off x="2523744" y="1782897"/>
+            <a:ext cx="438912" cy="155448"/>
+          </a:xfrm>
+          <a:prstGeom prst="rect">
+            <a:avLst/>
+          </a:prstGeom>
+          <a:noFill/>
+          <a:ln/>
+        </p:spPr>
+        <p:txBody>
+          <a:bodyPr wrap="square" lIns="0" tIns="0" rIns="0" bIns="0" rtlCol="0" anchor="ctr"/>
+          <a:lstStyle/>
+          <a:p>
+            <a:pPr algn="ctr" indent="0" marL="0">
+              <a:buNone/>
+            </a:pPr>
+            <a:r>
+              <a:rPr lang="en-US" sz="650" b="1" dirty="0">
+                <a:solidFill>
+                  <a:srgbClr val="00B4D8"/>
+                </a:solidFill>
+                <a:latin typeface="Calibri" pitchFamily="34" charset="0"/>
+                <a:ea typeface="Calibri" pitchFamily="34" charset="-122"/>
+                <a:cs typeface="Calibri" pitchFamily="34" charset="-120"/>
+              </a:rPr>
+              <a:t>25.2%</a:t>
+            </a:r>
+            <a:endParaRPr lang="en-US" sz="650" dirty="0"/>
+          </a:p>
+        </p:txBody>
+      </p:sp>
+      <p:sp>
+        <p:nvSpPr>
+          <p:cNvPr id="30" name="Text 28"/>
+          <p:cNvSpPr/>
+          <p:nvPr/>
+        </p:nvSpPr>
+        <p:spPr>
+          <a:xfrm>
+            <a:off x="2011680" y="3621024"/>
+            <a:ext cx="1051560" cy="347472"/>
+          </a:xfrm>
+          <a:prstGeom prst="rect">
+            <a:avLst/>
+          </a:prstGeom>
+          <a:noFill/>
+          <a:ln/>
+        </p:spPr>
+        <p:txBody>
+          <a:bodyPr wrap="square" lIns="0" tIns="0" rIns="0" bIns="0" rtlCol="0" anchor="ctr"/>
+          <a:lstStyle/>
+          <a:p>
+            <a:pPr algn="ctr" indent="0" marL="0">
+              <a:buNone/>
+            </a:pPr>
+            <a:r>
+              <a:rPr lang="en-US" sz="850" dirty="0">
+                <a:solidFill>
+                  <a:srgbClr val="0D1B2A"/>
+                </a:solidFill>
+                <a:latin typeface="Calibri" pitchFamily="34" charset="0"/>
+                <a:ea typeface="Calibri" pitchFamily="34" charset="-122"/>
+                <a:cs typeface="Calibri" pitchFamily="34" charset="-120"/>
+              </a:rPr>
+              <a:t>EEGNet</a:t>
+            </a:r>
+            <a:endParaRPr lang="en-US" sz="850" dirty="0"/>
+          </a:p>
+        </p:txBody>
+      </p:sp>
+      <p:sp>
+        <p:nvSpPr>
+          <p:cNvPr id="31" name="Shape 29"/>
+          <p:cNvSpPr/>
+          <p:nvPr/>
+        </p:nvSpPr>
+        <p:spPr>
+          <a:xfrm>
+            <a:off x="3300984" y="1705173"/>
+            <a:ext cx="347472" cy="1860987"/>
+          </a:xfrm>
+          <a:prstGeom prst="rect">
+            <a:avLst/>
+          </a:prstGeom>
+          <a:solidFill>
+            <a:srgbClr val="1A2A4A"/>
+          </a:solidFill>
+          <a:ln w="12700">
+            <a:solidFill>
+              <a:srgbClr val="1A2A4A"/>
+            </a:solidFill>
+            <a:prstDash val="solid"/>
+          </a:ln>
+        </p:spPr>
+      </p:sp>
+      <p:sp>
+        <p:nvSpPr>
+          <p:cNvPr id="32" name="Text 30"/>
+          <p:cNvSpPr/>
+          <p:nvPr/>
+        </p:nvSpPr>
+        <p:spPr>
+          <a:xfrm>
+            <a:off x="3255264" y="1540581"/>
+            <a:ext cx="438912" cy="155448"/>
+          </a:xfrm>
+          <a:prstGeom prst="rect">
+            <a:avLst/>
+          </a:prstGeom>
+          <a:noFill/>
+          <a:ln/>
+        </p:spPr>
+        <p:txBody>
+          <a:bodyPr wrap="square" lIns="0" tIns="0" rIns="0" bIns="0" rtlCol="0" anchor="ctr"/>
+          <a:lstStyle/>
+          <a:p>
+            <a:pPr algn="ctr" indent="0" marL="0">
+              <a:buNone/>
+            </a:pPr>
+            <a:r>
+              <a:rPr lang="en-US" sz="650" b="1" dirty="0">
+                <a:solidFill>
+                  <a:srgbClr val="1A2A4A"/>
+                </a:solidFill>
+                <a:latin typeface="Calibri" pitchFamily="34" charset="0"/>
+                <a:ea typeface="Calibri" pitchFamily="34" charset="-122"/>
+                <a:cs typeface="Calibri" pitchFamily="34" charset="-120"/>
+              </a:rPr>
+              <a:t>25.4%</a:t>
+            </a:r>
+            <a:endParaRPr lang="en-US" sz="650" dirty="0"/>
+          </a:p>
+        </p:txBody>
+      </p:sp>
+      <p:sp>
+        <p:nvSpPr>
+          <p:cNvPr id="33" name="Shape 31"/>
+          <p:cNvSpPr/>
+          <p:nvPr/>
+        </p:nvSpPr>
+        <p:spPr>
+          <a:xfrm>
+            <a:off x="3712464" y="1869948"/>
+            <a:ext cx="347472" cy="1696212"/>
+          </a:xfrm>
+          <a:prstGeom prst="rect">
+            <a:avLst/>
+          </a:prstGeom>
+          <a:solidFill>
+            <a:srgbClr val="00B4D8"/>
+          </a:solidFill>
+          <a:ln w="12700">
+            <a:solidFill>
+              <a:srgbClr val="00B4D8"/>
+            </a:solidFill>
+            <a:prstDash val="solid"/>
+          </a:ln>
+        </p:spPr>
+      </p:sp>
+      <p:sp>
+        <p:nvSpPr>
+          <p:cNvPr id="34" name="Text 32"/>
+          <p:cNvSpPr/>
+          <p:nvPr/>
+        </p:nvSpPr>
+        <p:spPr>
+          <a:xfrm>
+            <a:off x="3666744" y="1705356"/>
+            <a:ext cx="438912" cy="155448"/>
+          </a:xfrm>
+          <a:prstGeom prst="rect">
+            <a:avLst/>
+          </a:prstGeom>
+          <a:noFill/>
+          <a:ln/>
+        </p:spPr>
+        <p:txBody>
+          <a:bodyPr wrap="square" lIns="0" tIns="0" rIns="0" bIns="0" rtlCol="0" anchor="ctr"/>
+          <a:lstStyle/>
+          <a:p>
+            <a:pPr algn="ctr" indent="0" marL="0">
+              <a:buNone/>
+            </a:pPr>
+            <a:r>
+              <a:rPr lang="en-US" sz="650" b="1" dirty="0">
+                <a:solidFill>
+                  <a:srgbClr val="00B4D8"/>
+                </a:solidFill>
+                <a:latin typeface="Calibri" pitchFamily="34" charset="0"/>
+                <a:ea typeface="Calibri" pitchFamily="34" charset="-122"/>
+                <a:cs typeface="Calibri" pitchFamily="34" charset="-120"/>
+              </a:rPr>
+              <a:t>25.3%</a:t>
+            </a:r>
+            <a:endParaRPr lang="en-US" sz="650" dirty="0"/>
+          </a:p>
+        </p:txBody>
+      </p:sp>
+      <p:sp>
+        <p:nvSpPr>
+          <p:cNvPr id="35" name="Text 33"/>
+          <p:cNvSpPr/>
+          <p:nvPr/>
+        </p:nvSpPr>
+        <p:spPr>
+          <a:xfrm>
+            <a:off x="3154680" y="3621024"/>
+            <a:ext cx="1051560" cy="347472"/>
+          </a:xfrm>
+          <a:prstGeom prst="rect">
+            <a:avLst/>
+          </a:prstGeom>
+          <a:noFill/>
+          <a:ln/>
+        </p:spPr>
+        <p:txBody>
+          <a:bodyPr wrap="square" lIns="0" tIns="0" rIns="0" bIns="0" rtlCol="0" anchor="ctr"/>
+          <a:lstStyle/>
+          <a:p>
+            <a:pPr algn="ctr" indent="0" marL="0">
+              <a:buNone/>
+            </a:pPr>
+            <a:r>
+              <a:rPr lang="en-US" sz="850" dirty="0">
+                <a:solidFill>
+                  <a:srgbClr val="0D1B2A"/>
+                </a:solidFill>
+                <a:latin typeface="Calibri" pitchFamily="34" charset="0"/>
+                <a:ea typeface="Calibri" pitchFamily="34" charset="-122"/>
+                <a:cs typeface="Calibri" pitchFamily="34" charset="-120"/>
+              </a:rPr>
+              <a:t>Shallow</a:t>
+            </a:r>
+            <a:endParaRPr lang="en-US" sz="850" dirty="0"/>
+          </a:p>
+          <a:p>
+            <a:pPr algn="ctr" indent="0" marL="0">
+              <a:buNone/>
+            </a:pPr>
+            <a:r>
+              <a:rPr lang="en-US" sz="850" dirty="0">
+                <a:solidFill>
+                  <a:srgbClr val="0D1B2A"/>
+                </a:solidFill>
+                <a:latin typeface="Calibri" pitchFamily="34" charset="0"/>
+                <a:ea typeface="Calibri" pitchFamily="34" charset="-122"/>
+                <a:cs typeface="Calibri" pitchFamily="34" charset="-120"/>
+              </a:rPr>
+              <a:t>FBCSP</a:t>
+            </a:r>
+            <a:endParaRPr lang="en-US" sz="850" dirty="0"/>
+          </a:p>
+        </p:txBody>
+      </p:sp>
+      <p:sp>
+        <p:nvSpPr>
+          <p:cNvPr id="36" name="Shape 34"/>
+          <p:cNvSpPr/>
+          <p:nvPr/>
+        </p:nvSpPr>
+        <p:spPr>
+          <a:xfrm>
+            <a:off x="4443984" y="2073493"/>
+            <a:ext cx="347472" cy="1492667"/>
+          </a:xfrm>
+          <a:prstGeom prst="rect">
+            <a:avLst/>
+          </a:prstGeom>
+          <a:solidFill>
+            <a:srgbClr val="1A2A4A"/>
+          </a:solidFill>
+          <a:ln w="12700">
+            <a:solidFill>
+              <a:srgbClr val="1A2A4A"/>
+            </a:solidFill>
+            <a:prstDash val="solid"/>
+          </a:ln>
+        </p:spPr>
+      </p:sp>
+      <p:sp>
+        <p:nvSpPr>
+          <p:cNvPr id="37" name="Text 35"/>
+          <p:cNvSpPr/>
+          <p:nvPr/>
+        </p:nvSpPr>
+        <p:spPr>
+          <a:xfrm>
+            <a:off x="4398264" y="1908901"/>
+            <a:ext cx="438912" cy="155448"/>
+          </a:xfrm>
+          <a:prstGeom prst="rect">
+            <a:avLst/>
+          </a:prstGeom>
+          <a:noFill/>
+          <a:ln/>
+        </p:spPr>
+        <p:txBody>
+          <a:bodyPr wrap="square" lIns="0" tIns="0" rIns="0" bIns="0" rtlCol="0" anchor="ctr"/>
+          <a:lstStyle/>
+          <a:p>
+            <a:pPr algn="ctr" indent="0" marL="0">
+              <a:buNone/>
+            </a:pPr>
+            <a:r>
+              <a:rPr lang="en-US" sz="650" b="1" dirty="0">
+                <a:solidFill>
+                  <a:srgbClr val="1A2A4A"/>
+                </a:solidFill>
+                <a:latin typeface="Calibri" pitchFamily="34" charset="0"/>
+                <a:ea typeface="Calibri" pitchFamily="34" charset="-122"/>
+                <a:cs typeface="Calibri" pitchFamily="34" charset="-120"/>
+              </a:rPr>
+              <a:t>25.0%</a:t>
+            </a:r>
+            <a:endParaRPr lang="en-US" sz="650" dirty="0"/>
+          </a:p>
+        </p:txBody>
+      </p:sp>
+      <p:sp>
+        <p:nvSpPr>
+          <p:cNvPr id="38" name="Shape 36"/>
+          <p:cNvSpPr/>
+          <p:nvPr/>
+        </p:nvSpPr>
+        <p:spPr>
+          <a:xfrm>
+            <a:off x="4855464" y="2112264"/>
+            <a:ext cx="347472" cy="1453896"/>
+          </a:xfrm>
+          <a:prstGeom prst="rect">
+            <a:avLst/>
+          </a:prstGeom>
+          <a:solidFill>
+            <a:srgbClr val="00B4D8"/>
+          </a:solidFill>
+          <a:ln w="12700">
+            <a:solidFill>
+              <a:srgbClr val="00B4D8"/>
+            </a:solidFill>
+            <a:prstDash val="solid"/>
+          </a:ln>
+        </p:spPr>
+      </p:sp>
+      <p:sp>
+        <p:nvSpPr>
+          <p:cNvPr id="39" name="Text 37"/>
+          <p:cNvSpPr/>
+          <p:nvPr/>
+        </p:nvSpPr>
+        <p:spPr>
+          <a:xfrm>
+            <a:off x="4809744" y="1947672"/>
+            <a:ext cx="438912" cy="155448"/>
+          </a:xfrm>
+          <a:prstGeom prst="rect">
+            <a:avLst/>
+          </a:prstGeom>
+          <a:noFill/>
+          <a:ln/>
+        </p:spPr>
+        <p:txBody>
+          <a:bodyPr wrap="square" lIns="0" tIns="0" rIns="0" bIns="0" rtlCol="0" anchor="ctr"/>
+          <a:lstStyle/>
+          <a:p>
+            <a:pPr algn="ctr" indent="0" marL="0">
+              <a:buNone/>
+            </a:pPr>
+            <a:r>
+              <a:rPr lang="en-US" sz="650" b="1" dirty="0">
+                <a:solidFill>
+                  <a:srgbClr val="00B4D8"/>
+                </a:solidFill>
+                <a:latin typeface="Calibri" pitchFamily="34" charset="0"/>
+                <a:ea typeface="Calibri" pitchFamily="34" charset="-122"/>
+                <a:cs typeface="Calibri" pitchFamily="34" charset="-120"/>
+              </a:rPr>
+              <a:t>25.0%</a:t>
+            </a:r>
+            <a:endParaRPr lang="en-US" sz="650" dirty="0"/>
+          </a:p>
+        </p:txBody>
+      </p:sp>
+      <p:sp>
+        <p:nvSpPr>
+          <p:cNvPr id="40" name="Text 38"/>
+          <p:cNvSpPr/>
+          <p:nvPr/>
+        </p:nvSpPr>
+        <p:spPr>
+          <a:xfrm>
+            <a:off x="4297680" y="3621024"/>
+            <a:ext cx="1051560" cy="347472"/>
+          </a:xfrm>
+          <a:prstGeom prst="rect">
+            <a:avLst/>
+          </a:prstGeom>
+          <a:noFill/>
+          <a:ln/>
+        </p:spPr>
+        <p:txBody>
+          <a:bodyPr wrap="square" lIns="0" tIns="0" rIns="0" bIns="0" rtlCol="0" anchor="ctr"/>
+          <a:lstStyle/>
+          <a:p>
+            <a:pPr algn="ctr" indent="0" marL="0">
+              <a:buNone/>
+            </a:pPr>
+            <a:r>
+              <a:rPr lang="en-US" sz="850" dirty="0">
+                <a:solidFill>
+                  <a:srgbClr val="0D1B2A"/>
+                </a:solidFill>
+                <a:latin typeface="Calibri" pitchFamily="34" charset="0"/>
+                <a:ea typeface="Calibri" pitchFamily="34" charset="-122"/>
+                <a:cs typeface="Calibri" pitchFamily="34" charset="-120"/>
+              </a:rPr>
+              <a:t>Deep4Net</a:t>
+            </a:r>
+            <a:endParaRPr lang="en-US" sz="850" dirty="0"/>
+          </a:p>
+        </p:txBody>
+      </p:sp>
+      <p:sp>
+        <p:nvSpPr>
+          <p:cNvPr id="41" name="Shape 39"/>
+          <p:cNvSpPr/>
+          <p:nvPr/>
+        </p:nvSpPr>
+        <p:spPr>
+          <a:xfrm>
+            <a:off x="5586984" y="2112264"/>
+            <a:ext cx="347472" cy="1453896"/>
+          </a:xfrm>
+          <a:prstGeom prst="rect">
+            <a:avLst/>
+          </a:prstGeom>
+          <a:solidFill>
+            <a:srgbClr val="1A2A4A"/>
+          </a:solidFill>
+          <a:ln w="12700">
+            <a:solidFill>
+              <a:srgbClr val="1A2A4A"/>
+            </a:solidFill>
+            <a:prstDash val="solid"/>
+          </a:ln>
+        </p:spPr>
+      </p:sp>
+      <p:sp>
+        <p:nvSpPr>
+          <p:cNvPr id="42" name="Text 40"/>
+          <p:cNvSpPr/>
+          <p:nvPr/>
+        </p:nvSpPr>
+        <p:spPr>
+          <a:xfrm>
+            <a:off x="5541264" y="1947672"/>
+            <a:ext cx="438912" cy="155448"/>
+          </a:xfrm>
+          <a:prstGeom prst="rect">
+            <a:avLst/>
+          </a:prstGeom>
+          <a:noFill/>
+          <a:ln/>
+        </p:spPr>
+        <p:txBody>
+          <a:bodyPr wrap="square" lIns="0" tIns="0" rIns="0" bIns="0" rtlCol="0" anchor="ctr"/>
+          <a:lstStyle/>
+          <a:p>
+            <a:pPr algn="ctr" indent="0" marL="0">
+              <a:buNone/>
+            </a:pPr>
+            <a:r>
+              <a:rPr lang="en-US" sz="650" b="1" dirty="0">
+                <a:solidFill>
+                  <a:srgbClr val="1A2A4A"/>
+                </a:solidFill>
+                <a:latin typeface="Calibri" pitchFamily="34" charset="0"/>
+                <a:ea typeface="Calibri" pitchFamily="34" charset="-122"/>
+                <a:cs typeface="Calibri" pitchFamily="34" charset="-120"/>
+              </a:rPr>
+              <a:t>25.0%</a:t>
+            </a:r>
+            <a:endParaRPr lang="en-US" sz="650" dirty="0"/>
+          </a:p>
+        </p:txBody>
+      </p:sp>
+      <p:sp>
+        <p:nvSpPr>
+          <p:cNvPr id="43" name="Shape 41"/>
+          <p:cNvSpPr/>
+          <p:nvPr/>
+        </p:nvSpPr>
+        <p:spPr>
+          <a:xfrm>
+            <a:off x="5998464" y="2112264"/>
+            <a:ext cx="347472" cy="1453896"/>
+          </a:xfrm>
+          <a:prstGeom prst="rect">
+            <a:avLst/>
+          </a:prstGeom>
+          <a:solidFill>
+            <a:srgbClr val="00B4D8"/>
+          </a:solidFill>
+          <a:ln w="12700">
+            <a:solidFill>
+              <a:srgbClr val="00B4D8"/>
+            </a:solidFill>
+            <a:prstDash val="solid"/>
+          </a:ln>
+        </p:spPr>
+      </p:sp>
+      <p:sp>
+        <p:nvSpPr>
+          <p:cNvPr id="44" name="Text 42"/>
+          <p:cNvSpPr/>
+          <p:nvPr/>
+        </p:nvSpPr>
+        <p:spPr>
+          <a:xfrm>
+            <a:off x="5952744" y="1947672"/>
+            <a:ext cx="438912" cy="155448"/>
+          </a:xfrm>
+          <a:prstGeom prst="rect">
+            <a:avLst/>
+          </a:prstGeom>
+          <a:noFill/>
+          <a:ln/>
+        </p:spPr>
+        <p:txBody>
+          <a:bodyPr wrap="square" lIns="0" tIns="0" rIns="0" bIns="0" rtlCol="0" anchor="ctr"/>
+          <a:lstStyle/>
+          <a:p>
+            <a:pPr algn="ctr" indent="0" marL="0">
+              <a:buNone/>
+            </a:pPr>
+            <a:r>
+              <a:rPr lang="en-US" sz="650" b="1" dirty="0">
+                <a:solidFill>
+                  <a:srgbClr val="00B4D8"/>
+                </a:solidFill>
+                <a:latin typeface="Calibri" pitchFamily="34" charset="0"/>
+                <a:ea typeface="Calibri" pitchFamily="34" charset="-122"/>
+                <a:cs typeface="Calibri" pitchFamily="34" charset="-120"/>
+              </a:rPr>
+              <a:t>25.0%</a:t>
+            </a:r>
+            <a:endParaRPr lang="en-US" sz="650" dirty="0"/>
+          </a:p>
+        </p:txBody>
+      </p:sp>
+      <p:sp>
+        <p:nvSpPr>
+          <p:cNvPr id="45" name="Text 43"/>
+          <p:cNvSpPr/>
+          <p:nvPr/>
+        </p:nvSpPr>
+        <p:spPr>
+          <a:xfrm>
+            <a:off x="5440680" y="3621024"/>
+            <a:ext cx="1051560" cy="347472"/>
+          </a:xfrm>
+          <a:prstGeom prst="rect">
+            <a:avLst/>
+          </a:prstGeom>
+          <a:noFill/>
+          <a:ln/>
+        </p:spPr>
+        <p:txBody>
+          <a:bodyPr wrap="square" lIns="0" tIns="0" rIns="0" bIns="0" rtlCol="0" anchor="ctr"/>
+          <a:lstStyle/>
+          <a:p>
+            <a:pPr algn="ctr" indent="0" marL="0">
+              <a:buNone/>
+            </a:pPr>
+            <a:r>
+              <a:rPr lang="en-US" sz="850" dirty="0">
+                <a:solidFill>
+                  <a:srgbClr val="0D1B2A"/>
+                </a:solidFill>
+                <a:latin typeface="Calibri" pitchFamily="34" charset="0"/>
+                <a:ea typeface="Calibri" pitchFamily="34" charset="-122"/>
+                <a:cs typeface="Calibri" pitchFamily="34" charset="-120"/>
+              </a:rPr>
+              <a:t>EEG</a:t>
+            </a:r>
+            <a:endParaRPr lang="en-US" sz="850" dirty="0"/>
+          </a:p>
+          <a:p>
+            <a:pPr algn="ctr" indent="0" marL="0">
+              <a:buNone/>
+            </a:pPr>
+            <a:r>
+              <a:rPr lang="en-US" sz="850" dirty="0">
+                <a:solidFill>
+                  <a:srgbClr val="0D1B2A"/>
+                </a:solidFill>
+                <a:latin typeface="Calibri" pitchFamily="34" charset="0"/>
+                <a:ea typeface="Calibri" pitchFamily="34" charset="-122"/>
+                <a:cs typeface="Calibri" pitchFamily="34" charset="-120"/>
+              </a:rPr>
+              <a:t>Conformer</a:t>
+            </a:r>
+            <a:endParaRPr lang="en-US" sz="850" dirty="0"/>
+          </a:p>
+        </p:txBody>
+      </p:sp>
+      <p:sp>
+        <p:nvSpPr>
+          <p:cNvPr id="46" name="Shape 44"/>
+          <p:cNvSpPr/>
+          <p:nvPr/>
+        </p:nvSpPr>
+        <p:spPr>
+          <a:xfrm>
+            <a:off x="6729984" y="2063801"/>
+            <a:ext cx="347472" cy="1502359"/>
+          </a:xfrm>
+          <a:prstGeom prst="rect">
+            <a:avLst/>
+          </a:prstGeom>
+          <a:solidFill>
+            <a:srgbClr val="1A2A4A"/>
+          </a:solidFill>
+          <a:ln w="12700">
+            <a:solidFill>
+              <a:srgbClr val="1A2A4A"/>
+            </a:solidFill>
+            <a:prstDash val="solid"/>
+          </a:ln>
+        </p:spPr>
+      </p:sp>
+      <p:sp>
+        <p:nvSpPr>
+          <p:cNvPr id="47" name="Text 45"/>
+          <p:cNvSpPr/>
+          <p:nvPr/>
+        </p:nvSpPr>
+        <p:spPr>
+          <a:xfrm>
+            <a:off x="6684264" y="1899209"/>
+            <a:ext cx="438912" cy="155448"/>
+          </a:xfrm>
+          <a:prstGeom prst="rect">
+            <a:avLst/>
+          </a:prstGeom>
+          <a:noFill/>
+          <a:ln/>
+        </p:spPr>
+        <p:txBody>
+          <a:bodyPr wrap="square" lIns="0" tIns="0" rIns="0" bIns="0" rtlCol="0" anchor="ctr"/>
+          <a:lstStyle/>
+          <a:p>
+            <a:pPr algn="ctr" indent="0" marL="0">
+              <a:buNone/>
+            </a:pPr>
+            <a:r>
+              <a:rPr lang="en-US" sz="650" b="1" dirty="0">
+                <a:solidFill>
+                  <a:srgbClr val="1A2A4A"/>
+                </a:solidFill>
+                <a:latin typeface="Calibri" pitchFamily="34" charset="0"/>
+                <a:ea typeface="Calibri" pitchFamily="34" charset="-122"/>
+                <a:cs typeface="Calibri" pitchFamily="34" charset="-120"/>
+              </a:rPr>
+              <a:t>25.1%</a:t>
+            </a:r>
+            <a:endParaRPr lang="en-US" sz="650" dirty="0"/>
+          </a:p>
+        </p:txBody>
+      </p:sp>
+      <p:sp>
+        <p:nvSpPr>
+          <p:cNvPr id="48" name="Shape 46"/>
+          <p:cNvSpPr/>
+          <p:nvPr/>
+        </p:nvSpPr>
+        <p:spPr>
+          <a:xfrm>
+            <a:off x="7141464" y="2703515"/>
+            <a:ext cx="347472" cy="862645"/>
+          </a:xfrm>
+          <a:prstGeom prst="rect">
+            <a:avLst/>
+          </a:prstGeom>
+          <a:solidFill>
+            <a:srgbClr val="00B4D8"/>
+          </a:solidFill>
+          <a:ln w="12700">
+            <a:solidFill>
+              <a:srgbClr val="00B4D8"/>
+            </a:solidFill>
+            <a:prstDash val="solid"/>
+          </a:ln>
+        </p:spPr>
+      </p:sp>
+      <p:sp>
+        <p:nvSpPr>
+          <p:cNvPr id="49" name="Text 47"/>
+          <p:cNvSpPr/>
+          <p:nvPr/>
+        </p:nvSpPr>
+        <p:spPr>
+          <a:xfrm>
+            <a:off x="7095744" y="2538923"/>
+            <a:ext cx="438912" cy="155448"/>
+          </a:xfrm>
+          <a:prstGeom prst="rect">
+            <a:avLst/>
+          </a:prstGeom>
+          <a:noFill/>
+          <a:ln/>
+        </p:spPr>
+        <p:txBody>
+          <a:bodyPr wrap="square" lIns="0" tIns="0" rIns="0" bIns="0" rtlCol="0" anchor="ctr"/>
+          <a:lstStyle/>
+          <a:p>
+            <a:pPr algn="ctr" indent="0" marL="0">
+              <a:buNone/>
+            </a:pPr>
+            <a:r>
+              <a:rPr lang="en-US" sz="650" b="1" dirty="0">
+                <a:solidFill>
+                  <a:srgbClr val="00B4D8"/>
+                </a:solidFill>
+                <a:latin typeface="Calibri" pitchFamily="34" charset="0"/>
+                <a:ea typeface="Calibri" pitchFamily="34" charset="-122"/>
+                <a:cs typeface="Calibri" pitchFamily="34" charset="-120"/>
+              </a:rPr>
+              <a:t>24.4%</a:t>
+            </a:r>
+            <a:endParaRPr lang="en-US" sz="650" dirty="0"/>
+          </a:p>
+        </p:txBody>
+      </p:sp>
+      <p:sp>
+        <p:nvSpPr>
+          <p:cNvPr id="50" name="Text 48"/>
+          <p:cNvSpPr/>
+          <p:nvPr/>
+        </p:nvSpPr>
+        <p:spPr>
+          <a:xfrm>
+            <a:off x="6583680" y="3621024"/>
+            <a:ext cx="1051560" cy="347472"/>
+          </a:xfrm>
+          <a:prstGeom prst="rect">
+            <a:avLst/>
+          </a:prstGeom>
+          <a:noFill/>
+          <a:ln/>
+        </p:spPr>
+        <p:txBody>
+          <a:bodyPr wrap="square" lIns="0" tIns="0" rIns="0" bIns="0" rtlCol="0" anchor="ctr"/>
+          <a:lstStyle/>
+          <a:p>
+            <a:pPr algn="ctr" indent="0" marL="0">
+              <a:buNone/>
+            </a:pPr>
+            <a:r>
+              <a:rPr lang="en-US" sz="850" dirty="0">
+                <a:solidFill>
+                  <a:srgbClr val="0D1B2A"/>
+                </a:solidFill>
+                <a:latin typeface="Calibri" pitchFamily="34" charset="0"/>
+                <a:ea typeface="Calibri" pitchFamily="34" charset="-122"/>
+                <a:cs typeface="Calibri" pitchFamily="34" charset="-120"/>
+              </a:rPr>
+              <a:t>LaBraM</a:t>
+            </a:r>
+            <a:endParaRPr lang="en-US" sz="850" dirty="0"/>
+          </a:p>
+        </p:txBody>
+      </p:sp>
+      <p:sp>
+        <p:nvSpPr>
+          <p:cNvPr id="51" name="Shape 49"/>
+          <p:cNvSpPr/>
+          <p:nvPr/>
+        </p:nvSpPr>
+        <p:spPr>
+          <a:xfrm>
+            <a:off x="7754112" y="1645920"/>
+            <a:ext cx="201168" cy="164592"/>
+          </a:xfrm>
+          <a:prstGeom prst="rect">
+            <a:avLst/>
+          </a:prstGeom>
+          <a:solidFill>
+            <a:srgbClr val="1A2A4A"/>
+          </a:solidFill>
+          <a:ln w="12700">
+            <a:solidFill>
+              <a:srgbClr val="1A2A4A"/>
+            </a:solidFill>
+            <a:prstDash val="solid"/>
+          </a:ln>
+        </p:spPr>
+      </p:sp>
+      <p:sp>
+        <p:nvSpPr>
+          <p:cNvPr id="52" name="Text 50"/>
+          <p:cNvSpPr/>
+          <p:nvPr/>
+        </p:nvSpPr>
+        <p:spPr>
+          <a:xfrm>
+            <a:off x="8001000" y="1618488"/>
+            <a:ext cx="1005840" cy="219456"/>
+          </a:xfrm>
+          <a:prstGeom prst="rect">
+            <a:avLst/>
+          </a:prstGeom>
+          <a:noFill/>
+          <a:ln/>
+        </p:spPr>
+        <p:txBody>
+          <a:bodyPr wrap="square" lIns="0" tIns="0" rIns="0" bIns="0" rtlCol="0" anchor="ctr"/>
+          <a:lstStyle/>
+          <a:p>
+            <a:pPr indent="0" marL="0">
+              <a:buNone/>
+            </a:pPr>
+            <a:r>
+              <a:rPr lang="en-US" sz="850" dirty="0">
+                <a:solidFill>
+                  <a:srgbClr val="0D1B2A"/>
+                </a:solidFill>
+                <a:latin typeface="Calibri" pitchFamily="34" charset="0"/>
+                <a:ea typeface="Calibri" pitchFamily="34" charset="-122"/>
+                <a:cs typeface="Calibri" pitchFamily="34" charset="-120"/>
+              </a:rPr>
+              <a:t>No Norm</a:t>
+            </a:r>
+            <a:endParaRPr lang="en-US" sz="850" dirty="0"/>
+          </a:p>
+        </p:txBody>
+      </p:sp>
+      <p:sp>
+        <p:nvSpPr>
+          <p:cNvPr id="53" name="Shape 51"/>
+          <p:cNvSpPr/>
+          <p:nvPr/>
+        </p:nvSpPr>
+        <p:spPr>
+          <a:xfrm>
+            <a:off x="7754112" y="1892808"/>
+            <a:ext cx="201168" cy="164592"/>
+          </a:xfrm>
+          <a:prstGeom prst="rect">
+            <a:avLst/>
+          </a:prstGeom>
+          <a:solidFill>
+            <a:srgbClr val="00B4D8"/>
+          </a:solidFill>
+          <a:ln w="12700">
+            <a:solidFill>
+              <a:srgbClr val="00B4D8"/>
+            </a:solidFill>
+            <a:prstDash val="solid"/>
+          </a:ln>
+        </p:spPr>
+      </p:sp>
+      <p:sp>
+        <p:nvSpPr>
+          <p:cNvPr id="54" name="Text 52"/>
+          <p:cNvSpPr/>
+          <p:nvPr/>
+        </p:nvSpPr>
+        <p:spPr>
+          <a:xfrm>
+            <a:off x="8001000" y="1865376"/>
+            <a:ext cx="1005840" cy="219456"/>
+          </a:xfrm>
+          <a:prstGeom prst="rect">
+            <a:avLst/>
+          </a:prstGeom>
+          <a:noFill/>
+          <a:ln/>
+        </p:spPr>
+        <p:txBody>
+          <a:bodyPr wrap="square" lIns="0" tIns="0" rIns="0" bIns="0" rtlCol="0" anchor="ctr"/>
+          <a:lstStyle/>
+          <a:p>
+            <a:pPr indent="0" marL="0">
+              <a:buNone/>
+            </a:pPr>
+            <a:r>
+              <a:rPr lang="en-US" sz="850" dirty="0">
+                <a:solidFill>
+                  <a:srgbClr val="0D1B2A"/>
+                </a:solidFill>
+                <a:latin typeface="Calibri" pitchFamily="34" charset="0"/>
+                <a:ea typeface="Calibri" pitchFamily="34" charset="-122"/>
+                <a:cs typeface="Calibri" pitchFamily="34" charset="-120"/>
+              </a:rPr>
+              <a:t>+ Inst.Norm</a:t>
+            </a:r>
+            <a:endParaRPr lang="en-US" sz="850" dirty="0"/>
+          </a:p>
+        </p:txBody>
+      </p:sp>
+      <p:sp>
+        <p:nvSpPr>
+          <p:cNvPr id="55" name="Shape 53"/>
+          <p:cNvSpPr/>
+          <p:nvPr/>
+        </p:nvSpPr>
+        <p:spPr>
+          <a:xfrm>
+            <a:off x="365760" y="4133088"/>
+            <a:ext cx="8412480" cy="594360"/>
+          </a:xfrm>
+          <a:prstGeom prst="roundRect">
+            <a:avLst>
+              <a:gd name="adj" fmla="val 12308"/>
+            </a:avLst>
+          </a:prstGeom>
+          <a:solidFill>
+            <a:srgbClr val="E63946">
+              <a:alpha val="12000"/>
+            </a:srgbClr>
+          </a:solidFill>
+          <a:ln w="19050">
+            <a:solidFill>
+              <a:srgbClr val="E63946"/>
+            </a:solidFill>
+            <a:prstDash val="solid"/>
+          </a:ln>
+        </p:spPr>
+      </p:sp>
+      <p:sp>
+        <p:nvSpPr>
+          <p:cNvPr id="56" name="Text 54"/>
+          <p:cNvSpPr/>
+          <p:nvPr/>
+        </p:nvSpPr>
+        <p:spPr>
+          <a:xfrm>
+            <a:off x="548640" y="4178808"/>
+            <a:ext cx="8046720" cy="502920"/>
+          </a:xfrm>
+          <a:prstGeom prst="rect">
+            <a:avLst/>
+          </a:prstGeom>
+          <a:noFill/>
+          <a:ln/>
+        </p:spPr>
+        <p:txBody>
+          <a:bodyPr wrap="square" lIns="0" tIns="0" rIns="0" bIns="0" rtlCol="0" anchor="ctr"/>
+          <a:lstStyle/>
+          <a:p>
+            <a:pPr algn="ctr" indent="0" marL="0">
+              <a:buNone/>
+            </a:pPr>
+            <a:r>
+              <a:rPr lang="en-US" sz="1100" b="1" dirty="0">
+                <a:solidFill>
+                  <a:srgbClr val="E63946"/>
+                </a:solidFill>
+                <a:latin typeface="Calibri" pitchFamily="34" charset="0"/>
+                <a:ea typeface="Calibri" pitchFamily="34" charset="-122"/>
+                <a:cs typeface="Calibri" pitchFamily="34" charset="-120"/>
+              </a:rPr>
+              <a:t>⚠  All 6 models at chance — cross-subject generalization fails  |  Instance Norm has negligible effect  |  Best: ShallowFBCSP 25.4%</a:t>
+            </a:r>
+            <a:endParaRPr lang="en-US" sz="1100" dirty="0"/>
+          </a:p>
+        </p:txBody>
+      </p:sp>
+    </p:spTree>
+  </p:cSld>
+  <p:clrMapOvr>
+    <a:masterClrMapping/>
+  </p:clrMapOvr>
+</p:sld>
+</file>
+
+<file path=ppt/slides/slide12.xml><?xml version="1.0" encoding="utf-8"?>
+<p:sld xmlns:a="http://schemas.openxmlformats.org/drawingml/2006/main" xmlns:r="http://schemas.openxmlformats.org/officeDocument/2006/relationships" xmlns:p="http://schemas.openxmlformats.org/presentationml/2006/main">
+  <p:cSld name="Slide 12">
+    <p:bg>
+      <p:bgPr>
+        <a:solidFill>
+          <a:srgbClr val="FFFFFF"/>
+        </a:solidFill>
+      </p:bgPr>
+    </p:bg>
+    <p:spTree>
+      <p:nvGrpSpPr>
+        <p:cNvPr id="1" name=""/>
+        <p:cNvGrpSpPr/>
+        <p:nvPr/>
+      </p:nvGrpSpPr>
+      <p:grpSpPr>
+        <a:xfrm>
+          <a:off x="0" y="0"/>
+          <a:ext cx="0" cy="0"/>
+          <a:chOff x="0" y="0"/>
+          <a:chExt cx="0" cy="0"/>
+        </a:xfrm>
+      </p:grpSpPr>
+      <p:sp>
+        <p:nvSpPr>
+          <p:cNvPr id="2" name="Shape 0"/>
+          <p:cNvSpPr/>
+          <p:nvPr/>
+        </p:nvSpPr>
+        <p:spPr>
+          <a:xfrm>
+            <a:off x="0" y="0"/>
+            <a:ext cx="9144000" cy="73152"/>
+          </a:xfrm>
+          <a:prstGeom prst="rect">
+            <a:avLst/>
+          </a:prstGeom>
+          <a:solidFill>
+            <a:srgbClr val="00B4D8"/>
+          </a:solidFill>
+          <a:ln w="12700">
+            <a:solidFill>
+              <a:srgbClr val="00B4D8"/>
+            </a:solidFill>
+            <a:prstDash val="solid"/>
+          </a:ln>
+        </p:spPr>
+      </p:sp>
+      <p:sp>
+        <p:nvSpPr>
+          <p:cNvPr id="3" name="Text 1"/>
+          <p:cNvSpPr/>
+          <p:nvPr/>
+        </p:nvSpPr>
+        <p:spPr>
+          <a:xfrm>
+            <a:off x="365760" y="164592"/>
+            <a:ext cx="8412480" cy="502920"/>
+          </a:xfrm>
+          <a:prstGeom prst="rect">
+            <a:avLst/>
+          </a:prstGeom>
+          <a:noFill/>
+          <a:ln/>
+        </p:spPr>
+        <p:txBody>
+          <a:bodyPr wrap="square" lIns="0" tIns="0" rIns="0" bIns="0" rtlCol="0" anchor="ctr"/>
+          <a:lstStyle/>
+          <a:p>
+            <a:pPr indent="0" marL="0">
+              <a:buNone/>
+            </a:pPr>
+            <a:r>
+              <a:rPr lang="en-US" sz="2600" b="1" dirty="0">
+                <a:solidFill>
+                  <a:srgbClr val="1A2A4A"/>
+                </a:solidFill>
+                <a:latin typeface="Calibri" pitchFamily="34" charset="0"/>
+                <a:ea typeface="Calibri" pitchFamily="34" charset="-122"/>
+                <a:cs typeface="Calibri" pitchFamily="34" charset="-120"/>
+              </a:rPr>
+              <a:t>Subject-Specific Baseline Results</a:t>
+            </a:r>
+            <a:endParaRPr lang="en-US" sz="2600" dirty="0"/>
+          </a:p>
+        </p:txBody>
+      </p:sp>
+      <p:sp>
+        <p:nvSpPr>
+          <p:cNvPr id="4" name="Text 2"/>
+          <p:cNvSpPr/>
+          <p:nvPr/>
+        </p:nvSpPr>
+        <p:spPr>
+          <a:xfrm>
+            <a:off x="365760" y="658368"/>
+            <a:ext cx="8412480" cy="274320"/>
+          </a:xfrm>
+          <a:prstGeom prst="rect">
+            <a:avLst/>
+          </a:prstGeom>
+          <a:noFill/>
+          <a:ln/>
+        </p:spPr>
+        <p:txBody>
+          <a:bodyPr wrap="square" lIns="0" tIns="0" rIns="0" bIns="0" rtlCol="0" anchor="ctr"/>
+          <a:lstStyle/>
+          <a:p>
+            <a:pPr indent="0" marL="0">
+              <a:buNone/>
+            </a:pPr>
+            <a:r>
+              <a:rPr lang="en-US" sz="1300" dirty="0">
+                <a:solidFill>
+                  <a:srgbClr val="6B7A99"/>
+                </a:solidFill>
+                <a:latin typeface="Calibri" pitchFamily="34" charset="0"/>
+                <a:ea typeface="Calibri" pitchFamily="34" charset="-122"/>
+                <a:cs typeface="Calibri" pitchFamily="34" charset="-120"/>
+              </a:rPr>
+              <a:t>Leave-one-session-out  |  26 subjects  |  4 classes (concr4)  |  Chance = 25%  |  Mean balanced accuracy</a:t>
+            </a:r>
+            <a:endParaRPr lang="en-US" sz="1300" dirty="0"/>
+          </a:p>
+        </p:txBody>
+      </p:sp>
+      <p:sp>
+        <p:nvSpPr>
+          <p:cNvPr id="5" name="Shape 3"/>
+          <p:cNvSpPr/>
+          <p:nvPr/>
+        </p:nvSpPr>
+        <p:spPr>
+          <a:xfrm>
+            <a:off x="365760" y="960120"/>
+            <a:ext cx="8412480" cy="0"/>
+          </a:xfrm>
+          <a:prstGeom prst="line">
+            <a:avLst/>
+          </a:prstGeom>
+          <a:noFill/>
+          <a:ln w="19050">
+            <a:solidFill>
+              <a:srgbClr val="00B4D8"/>
+            </a:solidFill>
+            <a:prstDash val="solid"/>
+          </a:ln>
+        </p:spPr>
+      </p:sp>
+      <p:sp>
+        <p:nvSpPr>
+          <p:cNvPr id="6" name="Shape 4"/>
+          <p:cNvSpPr/>
+          <p:nvPr/>
+        </p:nvSpPr>
+        <p:spPr>
+          <a:xfrm>
+            <a:off x="822960" y="3566160"/>
+            <a:ext cx="6400800" cy="0"/>
+          </a:xfrm>
+          <a:prstGeom prst="line">
+            <a:avLst/>
+          </a:prstGeom>
+          <a:noFill/>
+          <a:ln w="12700">
+            <a:solidFill>
+              <a:srgbClr val="6B7A99"/>
+            </a:solidFill>
+            <a:prstDash val="solid"/>
+          </a:ln>
+        </p:spPr>
+      </p:sp>
+      <p:sp>
+        <p:nvSpPr>
+          <p:cNvPr id="7" name="Text 5"/>
+          <p:cNvSpPr/>
+          <p:nvPr/>
+        </p:nvSpPr>
+        <p:spPr>
+          <a:xfrm>
+            <a:off x="228600" y="3447288"/>
+            <a:ext cx="566928" cy="237744"/>
+          </a:xfrm>
+          <a:prstGeom prst="rect">
+            <a:avLst/>
+          </a:prstGeom>
+          <a:noFill/>
+          <a:ln/>
+        </p:spPr>
+        <p:txBody>
+          <a:bodyPr wrap="square" lIns="0" tIns="0" rIns="0" bIns="0" rtlCol="0" anchor="ctr"/>
+          <a:lstStyle/>
+          <a:p>
+            <a:pPr algn="r" indent="0" marL="0">
+              <a:buNone/>
+            </a:pPr>
+            <a:r>
+              <a:rPr lang="en-US" sz="800" dirty="0">
+                <a:solidFill>
+                  <a:srgbClr val="6B7A99"/>
+                </a:solidFill>
+                <a:latin typeface="Calibri" pitchFamily="34" charset="0"/>
+                <a:ea typeface="Calibri" pitchFamily="34" charset="-122"/>
+                <a:cs typeface="Calibri" pitchFamily="34" charset="-120"/>
+              </a:rPr>
+              <a:t>22.0%</a:t>
+            </a:r>
+            <a:endParaRPr lang="en-US" sz="800" dirty="0"/>
+          </a:p>
+        </p:txBody>
+      </p:sp>
+      <p:sp>
+        <p:nvSpPr>
+          <p:cNvPr id="8" name="Shape 6"/>
+          <p:cNvSpPr/>
+          <p:nvPr/>
+        </p:nvSpPr>
+        <p:spPr>
+          <a:xfrm>
+            <a:off x="822960" y="3081528"/>
+            <a:ext cx="6400800" cy="0"/>
+          </a:xfrm>
+          <a:prstGeom prst="line">
+            <a:avLst/>
+          </a:prstGeom>
+          <a:noFill/>
+          <a:ln w="6350">
+            <a:solidFill>
+              <a:srgbClr val="DDDDDD"/>
+            </a:solidFill>
+            <a:prstDash val="sysDot"/>
+          </a:ln>
+        </p:spPr>
+      </p:sp>
+      <p:sp>
+        <p:nvSpPr>
+          <p:cNvPr id="9" name="Text 7"/>
+          <p:cNvSpPr/>
+          <p:nvPr/>
+        </p:nvSpPr>
+        <p:spPr>
+          <a:xfrm>
+            <a:off x="228600" y="2962656"/>
+            <a:ext cx="566928" cy="237744"/>
+          </a:xfrm>
+          <a:prstGeom prst="rect">
+            <a:avLst/>
+          </a:prstGeom>
+          <a:noFill/>
+          <a:ln/>
+        </p:spPr>
+        <p:txBody>
+          <a:bodyPr wrap="square" lIns="0" tIns="0" rIns="0" bIns="0" rtlCol="0" anchor="ctr"/>
+          <a:lstStyle/>
+          <a:p>
+            <a:pPr algn="r" indent="0" marL="0">
+              <a:buNone/>
+            </a:pPr>
+            <a:r>
+              <a:rPr lang="en-US" sz="800" dirty="0">
+                <a:solidFill>
+                  <a:srgbClr val="6B7A99"/>
+                </a:solidFill>
+                <a:latin typeface="Calibri" pitchFamily="34" charset="0"/>
+                <a:ea typeface="Calibri" pitchFamily="34" charset="-122"/>
+                <a:cs typeface="Calibri" pitchFamily="34" charset="-120"/>
+              </a:rPr>
+              <a:t>24.2%</a:t>
+            </a:r>
+            <a:endParaRPr lang="en-US" sz="800" dirty="0"/>
+          </a:p>
+        </p:txBody>
+      </p:sp>
+      <p:sp>
+        <p:nvSpPr>
+          <p:cNvPr id="10" name="Shape 8"/>
+          <p:cNvSpPr/>
+          <p:nvPr/>
+        </p:nvSpPr>
+        <p:spPr>
+          <a:xfrm>
+            <a:off x="822960" y="2596896"/>
+            <a:ext cx="6400800" cy="0"/>
+          </a:xfrm>
+          <a:prstGeom prst="line">
+            <a:avLst/>
+          </a:prstGeom>
+          <a:noFill/>
+          <a:ln w="6350">
+            <a:solidFill>
+              <a:srgbClr val="DDDDDD"/>
+            </a:solidFill>
+            <a:prstDash val="sysDot"/>
+          </a:ln>
+        </p:spPr>
+      </p:sp>
+      <p:sp>
+        <p:nvSpPr>
+          <p:cNvPr id="11" name="Text 9"/>
+          <p:cNvSpPr/>
+          <p:nvPr/>
+        </p:nvSpPr>
+        <p:spPr>
+          <a:xfrm>
+            <a:off x="228600" y="2478024"/>
+            <a:ext cx="566928" cy="237744"/>
+          </a:xfrm>
+          <a:prstGeom prst="rect">
+            <a:avLst/>
+          </a:prstGeom>
+          <a:noFill/>
+          <a:ln/>
+        </p:spPr>
+        <p:txBody>
+          <a:bodyPr wrap="square" lIns="0" tIns="0" rIns="0" bIns="0" rtlCol="0" anchor="ctr"/>
+          <a:lstStyle/>
+          <a:p>
+            <a:pPr algn="r" indent="0" marL="0">
+              <a:buNone/>
+            </a:pPr>
+            <a:r>
+              <a:rPr lang="en-US" sz="800" dirty="0">
+                <a:solidFill>
+                  <a:srgbClr val="6B7A99"/>
+                </a:solidFill>
+                <a:latin typeface="Calibri" pitchFamily="34" charset="0"/>
+                <a:ea typeface="Calibri" pitchFamily="34" charset="-122"/>
+                <a:cs typeface="Calibri" pitchFamily="34" charset="-120"/>
+              </a:rPr>
+              <a:t>26.4%</a:t>
+            </a:r>
+            <a:endParaRPr lang="en-US" sz="800" dirty="0"/>
+          </a:p>
+        </p:txBody>
+      </p:sp>
+      <p:sp>
+        <p:nvSpPr>
+          <p:cNvPr id="12" name="Shape 10"/>
+          <p:cNvSpPr/>
+          <p:nvPr/>
+        </p:nvSpPr>
+        <p:spPr>
+          <a:xfrm>
+            <a:off x="822960" y="2112264"/>
+            <a:ext cx="6400800" cy="0"/>
+          </a:xfrm>
+          <a:prstGeom prst="line">
+            <a:avLst/>
+          </a:prstGeom>
+          <a:noFill/>
+          <a:ln w="6350">
+            <a:solidFill>
+              <a:srgbClr val="DDDDDD"/>
+            </a:solidFill>
+            <a:prstDash val="sysDot"/>
+          </a:ln>
+        </p:spPr>
+      </p:sp>
+      <p:sp>
+        <p:nvSpPr>
+          <p:cNvPr id="13" name="Text 11"/>
+          <p:cNvSpPr/>
+          <p:nvPr/>
+        </p:nvSpPr>
+        <p:spPr>
+          <a:xfrm>
+            <a:off x="228600" y="1993392"/>
+            <a:ext cx="566928" cy="237744"/>
+          </a:xfrm>
+          <a:prstGeom prst="rect">
+            <a:avLst/>
+          </a:prstGeom>
+          <a:noFill/>
+          <a:ln/>
+        </p:spPr>
+        <p:txBody>
+          <a:bodyPr wrap="square" lIns="0" tIns="0" rIns="0" bIns="0" rtlCol="0" anchor="ctr"/>
+          <a:lstStyle/>
+          <a:p>
+            <a:pPr algn="r" indent="0" marL="0">
+              <a:buNone/>
+            </a:pPr>
+            <a:r>
+              <a:rPr lang="en-US" sz="800" dirty="0">
+                <a:solidFill>
+                  <a:srgbClr val="6B7A99"/>
+                </a:solidFill>
+                <a:latin typeface="Calibri" pitchFamily="34" charset="0"/>
+                <a:ea typeface="Calibri" pitchFamily="34" charset="-122"/>
+                <a:cs typeface="Calibri" pitchFamily="34" charset="-120"/>
+              </a:rPr>
+              <a:t>28.6%</a:t>
+            </a:r>
+            <a:endParaRPr lang="en-US" sz="800" dirty="0"/>
+          </a:p>
+        </p:txBody>
+      </p:sp>
+      <p:sp>
+        <p:nvSpPr>
+          <p:cNvPr id="14" name="Shape 12"/>
+          <p:cNvSpPr/>
+          <p:nvPr/>
+        </p:nvSpPr>
+        <p:spPr>
+          <a:xfrm>
+            <a:off x="822960" y="1627632"/>
+            <a:ext cx="6400800" cy="0"/>
+          </a:xfrm>
+          <a:prstGeom prst="line">
+            <a:avLst/>
+          </a:prstGeom>
+          <a:noFill/>
+          <a:ln w="6350">
+            <a:solidFill>
+              <a:srgbClr val="DDDDDD"/>
+            </a:solidFill>
+            <a:prstDash val="sysDot"/>
+          </a:ln>
+        </p:spPr>
+      </p:sp>
+      <p:sp>
+        <p:nvSpPr>
+          <p:cNvPr id="15" name="Text 13"/>
+          <p:cNvSpPr/>
+          <p:nvPr/>
+        </p:nvSpPr>
+        <p:spPr>
+          <a:xfrm>
+            <a:off x="228600" y="1508760"/>
+            <a:ext cx="566928" cy="237744"/>
+          </a:xfrm>
+          <a:prstGeom prst="rect">
+            <a:avLst/>
+          </a:prstGeom>
+          <a:noFill/>
+          <a:ln/>
+        </p:spPr>
+        <p:txBody>
+          <a:bodyPr wrap="square" lIns="0" tIns="0" rIns="0" bIns="0" rtlCol="0" anchor="ctr"/>
+          <a:lstStyle/>
+          <a:p>
+            <a:pPr algn="r" indent="0" marL="0">
+              <a:buNone/>
+            </a:pPr>
+            <a:r>
+              <a:rPr lang="en-US" sz="800" dirty="0">
+                <a:solidFill>
+                  <a:srgbClr val="6B7A99"/>
+                </a:solidFill>
+                <a:latin typeface="Calibri" pitchFamily="34" charset="0"/>
+                <a:ea typeface="Calibri" pitchFamily="34" charset="-122"/>
+                <a:cs typeface="Calibri" pitchFamily="34" charset="-120"/>
+              </a:rPr>
+              <a:t>30.8%</a:t>
+            </a:r>
+            <a:endParaRPr lang="en-US" sz="800" dirty="0"/>
+          </a:p>
+        </p:txBody>
+      </p:sp>
+      <p:sp>
+        <p:nvSpPr>
+          <p:cNvPr id="16" name="Shape 14"/>
+          <p:cNvSpPr/>
+          <p:nvPr/>
+        </p:nvSpPr>
+        <p:spPr>
+          <a:xfrm>
+            <a:off x="822960" y="1143000"/>
+            <a:ext cx="6400800" cy="0"/>
+          </a:xfrm>
+          <a:prstGeom prst="line">
+            <a:avLst/>
+          </a:prstGeom>
+          <a:noFill/>
+          <a:ln w="6350">
+            <a:solidFill>
+              <a:srgbClr val="DDDDDD"/>
+            </a:solidFill>
+            <a:prstDash val="sysDot"/>
+          </a:ln>
+        </p:spPr>
+      </p:sp>
+      <p:sp>
+        <p:nvSpPr>
+          <p:cNvPr id="17" name="Text 15"/>
+          <p:cNvSpPr/>
+          <p:nvPr/>
+        </p:nvSpPr>
+        <p:spPr>
+          <a:xfrm>
+            <a:off x="228600" y="1024128"/>
+            <a:ext cx="566928" cy="237744"/>
+          </a:xfrm>
+          <a:prstGeom prst="rect">
+            <a:avLst/>
+          </a:prstGeom>
+          <a:noFill/>
+          <a:ln/>
+        </p:spPr>
+        <p:txBody>
+          <a:bodyPr wrap="square" lIns="0" tIns="0" rIns="0" bIns="0" rtlCol="0" anchor="ctr"/>
+          <a:lstStyle/>
+          <a:p>
+            <a:pPr algn="r" indent="0" marL="0">
+              <a:buNone/>
+            </a:pPr>
+            <a:r>
+              <a:rPr lang="en-US" sz="800" dirty="0">
+                <a:solidFill>
+                  <a:srgbClr val="6B7A99"/>
+                </a:solidFill>
+                <a:latin typeface="Calibri" pitchFamily="34" charset="0"/>
+                <a:ea typeface="Calibri" pitchFamily="34" charset="-122"/>
+                <a:cs typeface="Calibri" pitchFamily="34" charset="-120"/>
+              </a:rPr>
+              <a:t>33.0%</a:t>
+            </a:r>
+            <a:endParaRPr lang="en-US" sz="800" dirty="0"/>
+          </a:p>
+        </p:txBody>
+      </p:sp>
+      <p:sp>
+        <p:nvSpPr>
+          <p:cNvPr id="18" name="Shape 16"/>
+          <p:cNvSpPr/>
+          <p:nvPr/>
+        </p:nvSpPr>
+        <p:spPr>
+          <a:xfrm>
+            <a:off x="822960" y="1143000"/>
+            <a:ext cx="0" cy="2423160"/>
+          </a:xfrm>
+          <a:prstGeom prst="line">
+            <a:avLst/>
+          </a:prstGeom>
+          <a:noFill/>
+          <a:ln w="12700">
+            <a:solidFill>
+              <a:srgbClr val="6B7A99"/>
+            </a:solidFill>
+            <a:prstDash val="solid"/>
+          </a:ln>
+        </p:spPr>
+      </p:sp>
+      <p:sp>
+        <p:nvSpPr>
+          <p:cNvPr id="19" name="Shape 17"/>
+          <p:cNvSpPr/>
+          <p:nvPr/>
+        </p:nvSpPr>
+        <p:spPr>
+          <a:xfrm>
+            <a:off x="976884" y="2266465"/>
+            <a:ext cx="347472" cy="1299695"/>
+          </a:xfrm>
+          <a:prstGeom prst="rect">
+            <a:avLst/>
+          </a:prstGeom>
+          <a:solidFill>
+            <a:srgbClr val="1E5FAD"/>
+          </a:solidFill>
+          <a:ln w="12700">
+            <a:solidFill>
+              <a:srgbClr val="1E5FAD"/>
+            </a:solidFill>
+            <a:prstDash val="solid"/>
+          </a:ln>
+        </p:spPr>
+      </p:sp>
+      <p:sp>
+        <p:nvSpPr>
+          <p:cNvPr id="20" name="Text 18"/>
+          <p:cNvSpPr/>
+          <p:nvPr/>
+        </p:nvSpPr>
+        <p:spPr>
+          <a:xfrm>
+            <a:off x="931164" y="2101873"/>
+            <a:ext cx="438912" cy="155448"/>
+          </a:xfrm>
+          <a:prstGeom prst="rect">
+            <a:avLst/>
+          </a:prstGeom>
+          <a:noFill/>
+          <a:ln/>
+        </p:spPr>
+        <p:txBody>
+          <a:bodyPr wrap="square" lIns="0" tIns="0" rIns="0" bIns="0" rtlCol="0" anchor="ctr"/>
+          <a:lstStyle/>
+          <a:p>
+            <a:pPr algn="ctr" indent="0" marL="0">
+              <a:buNone/>
+            </a:pPr>
+            <a:r>
+              <a:rPr lang="en-US" sz="650" b="1" dirty="0">
+                <a:solidFill>
+                  <a:srgbClr val="1E5FAD"/>
+                </a:solidFill>
+                <a:latin typeface="Calibri" pitchFamily="34" charset="0"/>
+                <a:ea typeface="Calibri" pitchFamily="34" charset="-122"/>
+                <a:cs typeface="Calibri" pitchFamily="34" charset="-120"/>
+              </a:rPr>
+              <a:t>27.9%</a:t>
+            </a:r>
+            <a:endParaRPr lang="en-US" sz="650" dirty="0"/>
+          </a:p>
+        </p:txBody>
+      </p:sp>
+      <p:sp>
+        <p:nvSpPr>
+          <p:cNvPr id="21" name="Shape 19"/>
+          <p:cNvSpPr/>
+          <p:nvPr/>
+        </p:nvSpPr>
+        <p:spPr>
+          <a:xfrm>
+            <a:off x="1388364" y="2707040"/>
+            <a:ext cx="347472" cy="859120"/>
+          </a:xfrm>
+          <a:prstGeom prst="rect">
+            <a:avLst/>
+          </a:prstGeom>
+          <a:solidFill>
+            <a:srgbClr val="2EC4B6"/>
+          </a:solidFill>
+          <a:ln w="12700">
+            <a:solidFill>
+              <a:srgbClr val="2EC4B6"/>
+            </a:solidFill>
+            <a:prstDash val="solid"/>
+          </a:ln>
+        </p:spPr>
+      </p:sp>
+      <p:sp>
+        <p:nvSpPr>
+          <p:cNvPr id="22" name="Text 20"/>
+          <p:cNvSpPr/>
+          <p:nvPr/>
+        </p:nvSpPr>
+        <p:spPr>
+          <a:xfrm>
+            <a:off x="1342644" y="2542448"/>
+            <a:ext cx="438912" cy="155448"/>
+          </a:xfrm>
+          <a:prstGeom prst="rect">
+            <a:avLst/>
+          </a:prstGeom>
+          <a:noFill/>
+          <a:ln/>
+        </p:spPr>
+        <p:txBody>
+          <a:bodyPr wrap="square" lIns="0" tIns="0" rIns="0" bIns="0" rtlCol="0" anchor="ctr"/>
+          <a:lstStyle/>
+          <a:p>
+            <a:pPr algn="ctr" indent="0" marL="0">
+              <a:buNone/>
+            </a:pPr>
+            <a:r>
+              <a:rPr lang="en-US" sz="650" b="1" dirty="0">
+                <a:solidFill>
+                  <a:srgbClr val="2EC4B6"/>
+                </a:solidFill>
+                <a:latin typeface="Calibri" pitchFamily="34" charset="0"/>
+                <a:ea typeface="Calibri" pitchFamily="34" charset="-122"/>
+                <a:cs typeface="Calibri" pitchFamily="34" charset="-120"/>
+              </a:rPr>
+              <a:t>25.9%</a:t>
+            </a:r>
+            <a:endParaRPr lang="en-US" sz="650" dirty="0"/>
+          </a:p>
+        </p:txBody>
+      </p:sp>
+      <p:sp>
+        <p:nvSpPr>
+          <p:cNvPr id="23" name="Text 21"/>
+          <p:cNvSpPr/>
+          <p:nvPr/>
+        </p:nvSpPr>
+        <p:spPr>
+          <a:xfrm>
+            <a:off x="868680" y="3621024"/>
+            <a:ext cx="975360" cy="347472"/>
+          </a:xfrm>
+          <a:prstGeom prst="rect">
+            <a:avLst/>
+          </a:prstGeom>
+          <a:noFill/>
+          <a:ln/>
+        </p:spPr>
+        <p:txBody>
+          <a:bodyPr wrap="square" lIns="0" tIns="0" rIns="0" bIns="0" rtlCol="0" anchor="ctr"/>
+          <a:lstStyle/>
+          <a:p>
+            <a:pPr algn="ctr" indent="0" marL="0">
+              <a:buNone/>
+            </a:pPr>
+            <a:r>
+              <a:rPr lang="en-US" sz="850" dirty="0">
+                <a:solidFill>
+                  <a:srgbClr val="0D1B2A"/>
+                </a:solidFill>
+                <a:latin typeface="Calibri" pitchFamily="34" charset="0"/>
+                <a:ea typeface="Calibri" pitchFamily="34" charset="-122"/>
+                <a:cs typeface="Calibri" pitchFamily="34" charset="-120"/>
+              </a:rPr>
+              <a:t>EEGNet</a:t>
+            </a:r>
+            <a:endParaRPr lang="en-US" sz="850" dirty="0"/>
+          </a:p>
+        </p:txBody>
+      </p:sp>
+      <p:sp>
+        <p:nvSpPr>
+          <p:cNvPr id="24" name="Shape 22"/>
+          <p:cNvSpPr/>
+          <p:nvPr/>
+        </p:nvSpPr>
+        <p:spPr>
+          <a:xfrm>
+            <a:off x="2043684" y="1803862"/>
+            <a:ext cx="347472" cy="1762298"/>
+          </a:xfrm>
+          <a:prstGeom prst="rect">
+            <a:avLst/>
+          </a:prstGeom>
+          <a:solidFill>
+            <a:srgbClr val="1E5FAD"/>
+          </a:solidFill>
+          <a:ln w="12700">
+            <a:solidFill>
+              <a:srgbClr val="1E5FAD"/>
+            </a:solidFill>
+            <a:prstDash val="solid"/>
+          </a:ln>
+        </p:spPr>
+      </p:sp>
+      <p:sp>
+        <p:nvSpPr>
+          <p:cNvPr id="25" name="Text 23"/>
+          <p:cNvSpPr/>
+          <p:nvPr/>
+        </p:nvSpPr>
+        <p:spPr>
+          <a:xfrm>
+            <a:off x="1997964" y="1639270"/>
+            <a:ext cx="438912" cy="155448"/>
+          </a:xfrm>
+          <a:prstGeom prst="rect">
+            <a:avLst/>
+          </a:prstGeom>
+          <a:noFill/>
+          <a:ln/>
+        </p:spPr>
+        <p:txBody>
+          <a:bodyPr wrap="square" lIns="0" tIns="0" rIns="0" bIns="0" rtlCol="0" anchor="ctr"/>
+          <a:lstStyle/>
+          <a:p>
+            <a:pPr algn="ctr" indent="0" marL="0">
+              <a:buNone/>
+            </a:pPr>
+            <a:r>
+              <a:rPr lang="en-US" sz="650" b="1" dirty="0">
+                <a:solidFill>
+                  <a:srgbClr val="1E5FAD"/>
+                </a:solidFill>
+                <a:latin typeface="Calibri" pitchFamily="34" charset="0"/>
+                <a:ea typeface="Calibri" pitchFamily="34" charset="-122"/>
+                <a:cs typeface="Calibri" pitchFamily="34" charset="-120"/>
+              </a:rPr>
+              <a:t>30.0%</a:t>
+            </a:r>
+            <a:endParaRPr lang="en-US" sz="650" dirty="0"/>
+          </a:p>
+        </p:txBody>
+      </p:sp>
+      <p:sp>
+        <p:nvSpPr>
+          <p:cNvPr id="26" name="Shape 24"/>
+          <p:cNvSpPr/>
+          <p:nvPr/>
+        </p:nvSpPr>
+        <p:spPr>
+          <a:xfrm>
+            <a:off x="2455164" y="2773126"/>
+            <a:ext cx="347472" cy="793034"/>
+          </a:xfrm>
+          <a:prstGeom prst="rect">
+            <a:avLst/>
+          </a:prstGeom>
+          <a:solidFill>
+            <a:srgbClr val="2EC4B6"/>
+          </a:solidFill>
+          <a:ln w="12700">
+            <a:solidFill>
+              <a:srgbClr val="2EC4B6"/>
+            </a:solidFill>
+            <a:prstDash val="solid"/>
+          </a:ln>
+        </p:spPr>
+      </p:sp>
+      <p:sp>
+        <p:nvSpPr>
+          <p:cNvPr id="27" name="Text 25"/>
+          <p:cNvSpPr/>
+          <p:nvPr/>
+        </p:nvSpPr>
+        <p:spPr>
+          <a:xfrm>
+            <a:off x="2409444" y="2608534"/>
+            <a:ext cx="438912" cy="155448"/>
+          </a:xfrm>
+          <a:prstGeom prst="rect">
+            <a:avLst/>
+          </a:prstGeom>
+          <a:noFill/>
+          <a:ln/>
+        </p:spPr>
+        <p:txBody>
+          <a:bodyPr wrap="square" lIns="0" tIns="0" rIns="0" bIns="0" rtlCol="0" anchor="ctr"/>
+          <a:lstStyle/>
+          <a:p>
+            <a:pPr algn="ctr" indent="0" marL="0">
+              <a:buNone/>
+            </a:pPr>
+            <a:r>
+              <a:rPr lang="en-US" sz="650" b="1" dirty="0">
+                <a:solidFill>
+                  <a:srgbClr val="2EC4B6"/>
+                </a:solidFill>
+                <a:latin typeface="Calibri" pitchFamily="34" charset="0"/>
+                <a:ea typeface="Calibri" pitchFamily="34" charset="-122"/>
+                <a:cs typeface="Calibri" pitchFamily="34" charset="-120"/>
+              </a:rPr>
+              <a:t>25.6%</a:t>
+            </a:r>
+            <a:endParaRPr lang="en-US" sz="650" dirty="0"/>
+          </a:p>
+        </p:txBody>
+      </p:sp>
+      <p:sp>
+        <p:nvSpPr>
+          <p:cNvPr id="28" name="Text 26"/>
+          <p:cNvSpPr/>
+          <p:nvPr/>
+        </p:nvSpPr>
+        <p:spPr>
+          <a:xfrm>
+            <a:off x="1935480" y="3621024"/>
+            <a:ext cx="975360" cy="347472"/>
+          </a:xfrm>
+          <a:prstGeom prst="rect">
+            <a:avLst/>
+          </a:prstGeom>
+          <a:noFill/>
+          <a:ln/>
+        </p:spPr>
+        <p:txBody>
+          <a:bodyPr wrap="square" lIns="0" tIns="0" rIns="0" bIns="0" rtlCol="0" anchor="ctr"/>
+          <a:lstStyle/>
+          <a:p>
+            <a:pPr algn="ctr" indent="0" marL="0">
+              <a:buNone/>
+            </a:pPr>
+            <a:r>
+              <a:rPr lang="en-US" sz="850" dirty="0">
+                <a:solidFill>
+                  <a:srgbClr val="0D1B2A"/>
+                </a:solidFill>
+                <a:latin typeface="Calibri" pitchFamily="34" charset="0"/>
+                <a:ea typeface="Calibri" pitchFamily="34" charset="-122"/>
+                <a:cs typeface="Calibri" pitchFamily="34" charset="-120"/>
+              </a:rPr>
+              <a:t>Shallow</a:t>
+            </a:r>
+            <a:endParaRPr lang="en-US" sz="850" dirty="0"/>
+          </a:p>
+          <a:p>
+            <a:pPr algn="ctr" indent="0" marL="0">
+              <a:buNone/>
+            </a:pPr>
+            <a:r>
+              <a:rPr lang="en-US" sz="850" dirty="0">
+                <a:solidFill>
+                  <a:srgbClr val="0D1B2A"/>
+                </a:solidFill>
+                <a:latin typeface="Calibri" pitchFamily="34" charset="0"/>
+                <a:ea typeface="Calibri" pitchFamily="34" charset="-122"/>
+                <a:cs typeface="Calibri" pitchFamily="34" charset="-120"/>
+              </a:rPr>
+              <a:t>FBCSP</a:t>
+            </a:r>
+            <a:endParaRPr lang="en-US" sz="850" dirty="0"/>
+          </a:p>
+        </p:txBody>
+      </p:sp>
+      <p:sp>
+        <p:nvSpPr>
+          <p:cNvPr id="29" name="Shape 27"/>
+          <p:cNvSpPr/>
+          <p:nvPr/>
+        </p:nvSpPr>
+        <p:spPr>
+          <a:xfrm>
+            <a:off x="3110484" y="1891977"/>
+            <a:ext cx="347472" cy="1674183"/>
+          </a:xfrm>
+          <a:prstGeom prst="rect">
+            <a:avLst/>
+          </a:prstGeom>
+          <a:solidFill>
+            <a:srgbClr val="1E5FAD"/>
+          </a:solidFill>
+          <a:ln w="12700">
+            <a:solidFill>
+              <a:srgbClr val="1E5FAD"/>
+            </a:solidFill>
+            <a:prstDash val="solid"/>
+          </a:ln>
+        </p:spPr>
+      </p:sp>
+      <p:sp>
+        <p:nvSpPr>
+          <p:cNvPr id="30" name="Text 28"/>
+          <p:cNvSpPr/>
+          <p:nvPr/>
+        </p:nvSpPr>
+        <p:spPr>
+          <a:xfrm>
+            <a:off x="3064764" y="1727385"/>
+            <a:ext cx="438912" cy="155448"/>
+          </a:xfrm>
+          <a:prstGeom prst="rect">
+            <a:avLst/>
+          </a:prstGeom>
+          <a:noFill/>
+          <a:ln/>
+        </p:spPr>
+        <p:txBody>
+          <a:bodyPr wrap="square" lIns="0" tIns="0" rIns="0" bIns="0" rtlCol="0" anchor="ctr"/>
+          <a:lstStyle/>
+          <a:p>
+            <a:pPr algn="ctr" indent="0" marL="0">
+              <a:buNone/>
+            </a:pPr>
+            <a:r>
+              <a:rPr lang="en-US" sz="650" b="1" dirty="0">
+                <a:solidFill>
+                  <a:srgbClr val="1E5FAD"/>
+                </a:solidFill>
+                <a:latin typeface="Calibri" pitchFamily="34" charset="0"/>
+                <a:ea typeface="Calibri" pitchFamily="34" charset="-122"/>
+                <a:cs typeface="Calibri" pitchFamily="34" charset="-120"/>
+              </a:rPr>
+              <a:t>29.6%</a:t>
+            </a:r>
+            <a:endParaRPr lang="en-US" sz="650" dirty="0"/>
+          </a:p>
+        </p:txBody>
+      </p:sp>
+      <p:sp>
+        <p:nvSpPr>
+          <p:cNvPr id="31" name="Shape 29"/>
+          <p:cNvSpPr/>
+          <p:nvPr/>
+        </p:nvSpPr>
+        <p:spPr>
+          <a:xfrm>
+            <a:off x="3521964" y="3279787"/>
+            <a:ext cx="347472" cy="286373"/>
+          </a:xfrm>
+          <a:prstGeom prst="rect">
+            <a:avLst/>
+          </a:prstGeom>
+          <a:solidFill>
+            <a:srgbClr val="2EC4B6"/>
+          </a:solidFill>
+          <a:ln w="12700">
+            <a:solidFill>
+              <a:srgbClr val="2EC4B6"/>
+            </a:solidFill>
+            <a:prstDash val="solid"/>
+          </a:ln>
+        </p:spPr>
+      </p:sp>
+      <p:sp>
+        <p:nvSpPr>
+          <p:cNvPr id="32" name="Text 30"/>
+          <p:cNvSpPr/>
+          <p:nvPr/>
+        </p:nvSpPr>
+        <p:spPr>
+          <a:xfrm>
+            <a:off x="3476244" y="3115195"/>
+            <a:ext cx="438912" cy="155448"/>
+          </a:xfrm>
+          <a:prstGeom prst="rect">
+            <a:avLst/>
+          </a:prstGeom>
+          <a:noFill/>
+          <a:ln/>
+        </p:spPr>
+        <p:txBody>
+          <a:bodyPr wrap="square" lIns="0" tIns="0" rIns="0" bIns="0" rtlCol="0" anchor="ctr"/>
+          <a:lstStyle/>
+          <a:p>
+            <a:pPr algn="ctr" indent="0" marL="0">
+              <a:buNone/>
+            </a:pPr>
+            <a:r>
+              <a:rPr lang="en-US" sz="650" b="1" dirty="0">
+                <a:solidFill>
+                  <a:srgbClr val="2EC4B6"/>
+                </a:solidFill>
+                <a:latin typeface="Calibri" pitchFamily="34" charset="0"/>
+                <a:ea typeface="Calibri" pitchFamily="34" charset="-122"/>
+                <a:cs typeface="Calibri" pitchFamily="34" charset="-120"/>
+              </a:rPr>
+              <a:t>23.3%</a:t>
+            </a:r>
+            <a:endParaRPr lang="en-US" sz="650" dirty="0"/>
+          </a:p>
+        </p:txBody>
+      </p:sp>
+      <p:sp>
+        <p:nvSpPr>
+          <p:cNvPr id="33" name="Text 31"/>
+          <p:cNvSpPr/>
+          <p:nvPr/>
+        </p:nvSpPr>
+        <p:spPr>
+          <a:xfrm>
+            <a:off x="3002280" y="3621024"/>
+            <a:ext cx="975360" cy="347472"/>
+          </a:xfrm>
+          <a:prstGeom prst="rect">
+            <a:avLst/>
+          </a:prstGeom>
+          <a:noFill/>
+          <a:ln/>
+        </p:spPr>
+        <p:txBody>
+          <a:bodyPr wrap="square" lIns="0" tIns="0" rIns="0" bIns="0" rtlCol="0" anchor="ctr"/>
+          <a:lstStyle/>
+          <a:p>
+            <a:pPr algn="ctr" indent="0" marL="0">
+              <a:buNone/>
+            </a:pPr>
+            <a:r>
+              <a:rPr lang="en-US" sz="850" dirty="0">
+                <a:solidFill>
+                  <a:srgbClr val="0D1B2A"/>
+                </a:solidFill>
+                <a:latin typeface="Calibri" pitchFamily="34" charset="0"/>
+                <a:ea typeface="Calibri" pitchFamily="34" charset="-122"/>
+                <a:cs typeface="Calibri" pitchFamily="34" charset="-120"/>
+              </a:rPr>
+              <a:t>Deep4Net</a:t>
+            </a:r>
+            <a:endParaRPr lang="en-US" sz="850" dirty="0"/>
+          </a:p>
+        </p:txBody>
+      </p:sp>
+      <p:sp>
+        <p:nvSpPr>
+          <p:cNvPr id="34" name="Shape 32"/>
+          <p:cNvSpPr/>
+          <p:nvPr/>
+        </p:nvSpPr>
+        <p:spPr>
+          <a:xfrm>
+            <a:off x="4177284" y="2530810"/>
+            <a:ext cx="347472" cy="1035350"/>
+          </a:xfrm>
+          <a:prstGeom prst="rect">
+            <a:avLst/>
+          </a:prstGeom>
+          <a:solidFill>
+            <a:srgbClr val="1E5FAD"/>
+          </a:solidFill>
+          <a:ln w="12700">
+            <a:solidFill>
+              <a:srgbClr val="1E5FAD"/>
+            </a:solidFill>
+            <a:prstDash val="solid"/>
+          </a:ln>
+        </p:spPr>
+      </p:sp>
+      <p:sp>
+        <p:nvSpPr>
+          <p:cNvPr id="35" name="Text 33"/>
+          <p:cNvSpPr/>
+          <p:nvPr/>
+        </p:nvSpPr>
+        <p:spPr>
+          <a:xfrm>
+            <a:off x="4131564" y="2366218"/>
+            <a:ext cx="438912" cy="155448"/>
+          </a:xfrm>
+          <a:prstGeom prst="rect">
+            <a:avLst/>
+          </a:prstGeom>
+          <a:noFill/>
+          <a:ln/>
+        </p:spPr>
+        <p:txBody>
+          <a:bodyPr wrap="square" lIns="0" tIns="0" rIns="0" bIns="0" rtlCol="0" anchor="ctr"/>
+          <a:lstStyle/>
+          <a:p>
+            <a:pPr algn="ctr" indent="0" marL="0">
+              <a:buNone/>
+            </a:pPr>
+            <a:r>
+              <a:rPr lang="en-US" sz="650" b="1" dirty="0">
+                <a:solidFill>
+                  <a:srgbClr val="1E5FAD"/>
+                </a:solidFill>
+                <a:latin typeface="Calibri" pitchFamily="34" charset="0"/>
+                <a:ea typeface="Calibri" pitchFamily="34" charset="-122"/>
+                <a:cs typeface="Calibri" pitchFamily="34" charset="-120"/>
+              </a:rPr>
+              <a:t>26.7%</a:t>
+            </a:r>
+            <a:endParaRPr lang="en-US" sz="650" dirty="0"/>
+          </a:p>
+        </p:txBody>
+      </p:sp>
+      <p:sp>
+        <p:nvSpPr>
+          <p:cNvPr id="36" name="Shape 34"/>
+          <p:cNvSpPr/>
+          <p:nvPr/>
+        </p:nvSpPr>
+        <p:spPr>
+          <a:xfrm>
+            <a:off x="4588764" y="2861241"/>
+            <a:ext cx="347472" cy="704919"/>
+          </a:xfrm>
+          <a:prstGeom prst="rect">
+            <a:avLst/>
+          </a:prstGeom>
+          <a:solidFill>
+            <a:srgbClr val="2EC4B6"/>
+          </a:solidFill>
+          <a:ln w="12700">
+            <a:solidFill>
+              <a:srgbClr val="2EC4B6"/>
+            </a:solidFill>
+            <a:prstDash val="solid"/>
+          </a:ln>
+        </p:spPr>
+      </p:sp>
+      <p:sp>
+        <p:nvSpPr>
+          <p:cNvPr id="37" name="Text 35"/>
+          <p:cNvSpPr/>
+          <p:nvPr/>
+        </p:nvSpPr>
+        <p:spPr>
+          <a:xfrm>
+            <a:off x="4543044" y="2696649"/>
+            <a:ext cx="438912" cy="155448"/>
+          </a:xfrm>
+          <a:prstGeom prst="rect">
+            <a:avLst/>
+          </a:prstGeom>
+          <a:noFill/>
+          <a:ln/>
+        </p:spPr>
+        <p:txBody>
+          <a:bodyPr wrap="square" lIns="0" tIns="0" rIns="0" bIns="0" rtlCol="0" anchor="ctr"/>
+          <a:lstStyle/>
+          <a:p>
+            <a:pPr algn="ctr" indent="0" marL="0">
+              <a:buNone/>
+            </a:pPr>
+            <a:r>
+              <a:rPr lang="en-US" sz="650" b="1" dirty="0">
+                <a:solidFill>
+                  <a:srgbClr val="2EC4B6"/>
+                </a:solidFill>
+                <a:latin typeface="Calibri" pitchFamily="34" charset="0"/>
+                <a:ea typeface="Calibri" pitchFamily="34" charset="-122"/>
+                <a:cs typeface="Calibri" pitchFamily="34" charset="-120"/>
+              </a:rPr>
+              <a:t>25.2%</a:t>
+            </a:r>
+            <a:endParaRPr lang="en-US" sz="650" dirty="0"/>
+          </a:p>
+        </p:txBody>
+      </p:sp>
+      <p:sp>
+        <p:nvSpPr>
+          <p:cNvPr id="38" name="Text 36"/>
+          <p:cNvSpPr/>
+          <p:nvPr/>
+        </p:nvSpPr>
+        <p:spPr>
+          <a:xfrm>
+            <a:off x="4069080" y="3621024"/>
+            <a:ext cx="975360" cy="347472"/>
+          </a:xfrm>
+          <a:prstGeom prst="rect">
+            <a:avLst/>
+          </a:prstGeom>
+          <a:noFill/>
+          <a:ln/>
+        </p:spPr>
+        <p:txBody>
+          <a:bodyPr wrap="square" lIns="0" tIns="0" rIns="0" bIns="0" rtlCol="0" anchor="ctr"/>
+          <a:lstStyle/>
+          <a:p>
+            <a:pPr algn="ctr" indent="0" marL="0">
+              <a:buNone/>
+            </a:pPr>
+            <a:r>
+              <a:rPr lang="en-US" sz="850" dirty="0">
+                <a:solidFill>
+                  <a:srgbClr val="0D1B2A"/>
+                </a:solidFill>
+                <a:latin typeface="Calibri" pitchFamily="34" charset="0"/>
+                <a:ea typeface="Calibri" pitchFamily="34" charset="-122"/>
+                <a:cs typeface="Calibri" pitchFamily="34" charset="-120"/>
+              </a:rPr>
+              <a:t>EEG</a:t>
+            </a:r>
+            <a:endParaRPr lang="en-US" sz="850" dirty="0"/>
+          </a:p>
+          <a:p>
+            <a:pPr algn="ctr" indent="0" marL="0">
+              <a:buNone/>
+            </a:pPr>
+            <a:r>
+              <a:rPr lang="en-US" sz="850" dirty="0">
+                <a:solidFill>
+                  <a:srgbClr val="0D1B2A"/>
+                </a:solidFill>
+                <a:latin typeface="Calibri" pitchFamily="34" charset="0"/>
+                <a:ea typeface="Calibri" pitchFamily="34" charset="-122"/>
+                <a:cs typeface="Calibri" pitchFamily="34" charset="-120"/>
+              </a:rPr>
+              <a:t>Conformer</a:t>
+            </a:r>
+            <a:endParaRPr lang="en-US" sz="850" dirty="0"/>
+          </a:p>
+        </p:txBody>
+      </p:sp>
+      <p:sp>
+        <p:nvSpPr>
+          <p:cNvPr id="39" name="Shape 37"/>
+          <p:cNvSpPr/>
+          <p:nvPr/>
+        </p:nvSpPr>
+        <p:spPr>
+          <a:xfrm>
+            <a:off x="5244084" y="2354580"/>
+            <a:ext cx="347472" cy="1211580"/>
+          </a:xfrm>
+          <a:prstGeom prst="rect">
+            <a:avLst/>
+          </a:prstGeom>
+          <a:solidFill>
+            <a:srgbClr val="1E5FAD"/>
+          </a:solidFill>
+          <a:ln w="12700">
+            <a:solidFill>
+              <a:srgbClr val="1E5FAD"/>
+            </a:solidFill>
+            <a:prstDash val="solid"/>
+          </a:ln>
+        </p:spPr>
+      </p:sp>
+      <p:sp>
+        <p:nvSpPr>
+          <p:cNvPr id="40" name="Text 38"/>
+          <p:cNvSpPr/>
+          <p:nvPr/>
+        </p:nvSpPr>
+        <p:spPr>
+          <a:xfrm>
+            <a:off x="5198364" y="2189988"/>
+            <a:ext cx="438912" cy="155448"/>
+          </a:xfrm>
+          <a:prstGeom prst="rect">
+            <a:avLst/>
+          </a:prstGeom>
+          <a:noFill/>
+          <a:ln/>
+        </p:spPr>
+        <p:txBody>
+          <a:bodyPr wrap="square" lIns="0" tIns="0" rIns="0" bIns="0" rtlCol="0" anchor="ctr"/>
+          <a:lstStyle/>
+          <a:p>
+            <a:pPr algn="ctr" indent="0" marL="0">
+              <a:buNone/>
+            </a:pPr>
+            <a:r>
+              <a:rPr lang="en-US" sz="650" b="1" dirty="0">
+                <a:solidFill>
+                  <a:srgbClr val="1E5FAD"/>
+                </a:solidFill>
+                <a:latin typeface="Calibri" pitchFamily="34" charset="0"/>
+                <a:ea typeface="Calibri" pitchFamily="34" charset="-122"/>
+                <a:cs typeface="Calibri" pitchFamily="34" charset="-120"/>
+              </a:rPr>
+              <a:t>27.5%</a:t>
+            </a:r>
+            <a:endParaRPr lang="en-US" sz="650" dirty="0"/>
+          </a:p>
+        </p:txBody>
+      </p:sp>
+      <p:sp>
+        <p:nvSpPr>
+          <p:cNvPr id="41" name="Shape 39"/>
+          <p:cNvSpPr/>
+          <p:nvPr/>
+        </p:nvSpPr>
+        <p:spPr>
+          <a:xfrm>
+            <a:off x="5655564" y="3169643"/>
+            <a:ext cx="347472" cy="396517"/>
+          </a:xfrm>
+          <a:prstGeom prst="rect">
+            <a:avLst/>
+          </a:prstGeom>
+          <a:solidFill>
+            <a:srgbClr val="2EC4B6"/>
+          </a:solidFill>
+          <a:ln w="12700">
+            <a:solidFill>
+              <a:srgbClr val="2EC4B6"/>
+            </a:solidFill>
+            <a:prstDash val="solid"/>
+          </a:ln>
+        </p:spPr>
+      </p:sp>
+      <p:sp>
+        <p:nvSpPr>
+          <p:cNvPr id="42" name="Text 40"/>
+          <p:cNvSpPr/>
+          <p:nvPr/>
+        </p:nvSpPr>
+        <p:spPr>
+          <a:xfrm>
+            <a:off x="5609844" y="3005051"/>
+            <a:ext cx="438912" cy="155448"/>
+          </a:xfrm>
+          <a:prstGeom prst="rect">
+            <a:avLst/>
+          </a:prstGeom>
+          <a:noFill/>
+          <a:ln/>
+        </p:spPr>
+        <p:txBody>
+          <a:bodyPr wrap="square" lIns="0" tIns="0" rIns="0" bIns="0" rtlCol="0" anchor="ctr"/>
+          <a:lstStyle/>
+          <a:p>
+            <a:pPr algn="ctr" indent="0" marL="0">
+              <a:buNone/>
+            </a:pPr>
+            <a:r>
+              <a:rPr lang="en-US" sz="650" b="1" dirty="0">
+                <a:solidFill>
+                  <a:srgbClr val="2EC4B6"/>
+                </a:solidFill>
+                <a:latin typeface="Calibri" pitchFamily="34" charset="0"/>
+                <a:ea typeface="Calibri" pitchFamily="34" charset="-122"/>
+                <a:cs typeface="Calibri" pitchFamily="34" charset="-120"/>
+              </a:rPr>
+              <a:t>23.8%</a:t>
+            </a:r>
+            <a:endParaRPr lang="en-US" sz="650" dirty="0"/>
+          </a:p>
+        </p:txBody>
+      </p:sp>
+      <p:sp>
+        <p:nvSpPr>
+          <p:cNvPr id="43" name="Text 41"/>
+          <p:cNvSpPr/>
+          <p:nvPr/>
+        </p:nvSpPr>
+        <p:spPr>
+          <a:xfrm>
+            <a:off x="5135880" y="3621024"/>
+            <a:ext cx="975360" cy="347472"/>
+          </a:xfrm>
+          <a:prstGeom prst="rect">
+            <a:avLst/>
+          </a:prstGeom>
+          <a:noFill/>
+          <a:ln/>
+        </p:spPr>
+        <p:txBody>
+          <a:bodyPr wrap="square" lIns="0" tIns="0" rIns="0" bIns="0" rtlCol="0" anchor="ctr"/>
+          <a:lstStyle/>
+          <a:p>
+            <a:pPr algn="ctr" indent="0" marL="0">
+              <a:buNone/>
+            </a:pPr>
+            <a:r>
+              <a:rPr lang="en-US" sz="850" dirty="0">
+                <a:solidFill>
+                  <a:srgbClr val="0D1B2A"/>
+                </a:solidFill>
+                <a:latin typeface="Calibri" pitchFamily="34" charset="0"/>
+                <a:ea typeface="Calibri" pitchFamily="34" charset="-122"/>
+                <a:cs typeface="Calibri" pitchFamily="34" charset="-120"/>
+              </a:rPr>
+              <a:t>ATCNet</a:t>
+            </a:r>
+            <a:endParaRPr lang="en-US" sz="850" dirty="0"/>
+          </a:p>
+        </p:txBody>
+      </p:sp>
+      <p:sp>
+        <p:nvSpPr>
+          <p:cNvPr id="44" name="Shape 42"/>
+          <p:cNvSpPr/>
+          <p:nvPr/>
+        </p:nvSpPr>
+        <p:spPr>
+          <a:xfrm>
+            <a:off x="6310884" y="2288494"/>
+            <a:ext cx="347472" cy="1277666"/>
+          </a:xfrm>
+          <a:prstGeom prst="rect">
+            <a:avLst/>
+          </a:prstGeom>
+          <a:solidFill>
+            <a:srgbClr val="1E5FAD"/>
+          </a:solidFill>
+          <a:ln w="12700">
+            <a:solidFill>
+              <a:srgbClr val="1E5FAD"/>
+            </a:solidFill>
+            <a:prstDash val="solid"/>
+          </a:ln>
+        </p:spPr>
+      </p:sp>
+      <p:sp>
+        <p:nvSpPr>
+          <p:cNvPr id="45" name="Text 43"/>
+          <p:cNvSpPr/>
+          <p:nvPr/>
+        </p:nvSpPr>
+        <p:spPr>
+          <a:xfrm>
+            <a:off x="6265164" y="2123902"/>
+            <a:ext cx="438912" cy="155448"/>
+          </a:xfrm>
+          <a:prstGeom prst="rect">
+            <a:avLst/>
+          </a:prstGeom>
+          <a:noFill/>
+          <a:ln/>
+        </p:spPr>
+        <p:txBody>
+          <a:bodyPr wrap="square" lIns="0" tIns="0" rIns="0" bIns="0" rtlCol="0" anchor="ctr"/>
+          <a:lstStyle/>
+          <a:p>
+            <a:pPr algn="ctr" indent="0" marL="0">
+              <a:buNone/>
+            </a:pPr>
+            <a:r>
+              <a:rPr lang="en-US" sz="650" b="1" dirty="0">
+                <a:solidFill>
+                  <a:srgbClr val="1E5FAD"/>
+                </a:solidFill>
+                <a:latin typeface="Calibri" pitchFamily="34" charset="0"/>
+                <a:ea typeface="Calibri" pitchFamily="34" charset="-122"/>
+                <a:cs typeface="Calibri" pitchFamily="34" charset="-120"/>
+              </a:rPr>
+              <a:t>27.8%</a:t>
+            </a:r>
+            <a:endParaRPr lang="en-US" sz="650" dirty="0"/>
+          </a:p>
+        </p:txBody>
+      </p:sp>
+      <p:sp>
+        <p:nvSpPr>
+          <p:cNvPr id="46" name="Shape 44"/>
+          <p:cNvSpPr/>
+          <p:nvPr/>
+        </p:nvSpPr>
+        <p:spPr>
+          <a:xfrm>
+            <a:off x="6722364" y="2927327"/>
+            <a:ext cx="347472" cy="638833"/>
+          </a:xfrm>
+          <a:prstGeom prst="rect">
+            <a:avLst/>
+          </a:prstGeom>
+          <a:solidFill>
+            <a:srgbClr val="2EC4B6"/>
+          </a:solidFill>
+          <a:ln w="12700">
+            <a:solidFill>
+              <a:srgbClr val="2EC4B6"/>
+            </a:solidFill>
+            <a:prstDash val="solid"/>
+          </a:ln>
+        </p:spPr>
+      </p:sp>
+      <p:sp>
+        <p:nvSpPr>
+          <p:cNvPr id="47" name="Text 45"/>
+          <p:cNvSpPr/>
+          <p:nvPr/>
+        </p:nvSpPr>
+        <p:spPr>
+          <a:xfrm>
+            <a:off x="6676644" y="2762735"/>
+            <a:ext cx="438912" cy="155448"/>
+          </a:xfrm>
+          <a:prstGeom prst="rect">
+            <a:avLst/>
+          </a:prstGeom>
+          <a:noFill/>
+          <a:ln/>
+        </p:spPr>
+        <p:txBody>
+          <a:bodyPr wrap="square" lIns="0" tIns="0" rIns="0" bIns="0" rtlCol="0" anchor="ctr"/>
+          <a:lstStyle/>
+          <a:p>
+            <a:pPr algn="ctr" indent="0" marL="0">
+              <a:buNone/>
+            </a:pPr>
+            <a:r>
+              <a:rPr lang="en-US" sz="650" b="1" dirty="0">
+                <a:solidFill>
+                  <a:srgbClr val="2EC4B6"/>
+                </a:solidFill>
+                <a:latin typeface="Calibri" pitchFamily="34" charset="0"/>
+                <a:ea typeface="Calibri" pitchFamily="34" charset="-122"/>
+                <a:cs typeface="Calibri" pitchFamily="34" charset="-120"/>
+              </a:rPr>
+              <a:t>24.9%</a:t>
+            </a:r>
+            <a:endParaRPr lang="en-US" sz="650" dirty="0"/>
+          </a:p>
+        </p:txBody>
+      </p:sp>
+      <p:sp>
+        <p:nvSpPr>
+          <p:cNvPr id="48" name="Text 46"/>
+          <p:cNvSpPr/>
+          <p:nvPr/>
+        </p:nvSpPr>
+        <p:spPr>
+          <a:xfrm>
+            <a:off x="6202680" y="3621024"/>
+            <a:ext cx="975360" cy="347472"/>
+          </a:xfrm>
+          <a:prstGeom prst="rect">
+            <a:avLst/>
+          </a:prstGeom>
+          <a:noFill/>
+          <a:ln/>
+        </p:spPr>
+        <p:txBody>
+          <a:bodyPr wrap="square" lIns="0" tIns="0" rIns="0" bIns="0" rtlCol="0" anchor="ctr"/>
+          <a:lstStyle/>
+          <a:p>
+            <a:pPr algn="ctr" indent="0" marL="0">
+              <a:buNone/>
+            </a:pPr>
+            <a:r>
+              <a:rPr lang="en-US" sz="850" dirty="0">
+                <a:solidFill>
+                  <a:srgbClr val="0D1B2A"/>
+                </a:solidFill>
+                <a:latin typeface="Calibri" pitchFamily="34" charset="0"/>
+                <a:ea typeface="Calibri" pitchFamily="34" charset="-122"/>
+                <a:cs typeface="Calibri" pitchFamily="34" charset="-120"/>
+              </a:rPr>
+              <a:t>LaBraM</a:t>
+            </a:r>
+            <a:endParaRPr lang="en-US" sz="850" dirty="0"/>
+          </a:p>
+        </p:txBody>
+      </p:sp>
+      <p:sp>
+        <p:nvSpPr>
+          <p:cNvPr id="49" name="Shape 47"/>
+          <p:cNvSpPr/>
+          <p:nvPr/>
+        </p:nvSpPr>
+        <p:spPr>
+          <a:xfrm>
+            <a:off x="822960" y="2905298"/>
+            <a:ext cx="6400800" cy="0"/>
+          </a:xfrm>
+          <a:prstGeom prst="line">
+            <a:avLst/>
+          </a:prstGeom>
+          <a:noFill/>
+          <a:ln w="19050">
+            <a:solidFill>
+              <a:srgbClr val="E63946"/>
+            </a:solidFill>
+            <a:prstDash val="dash"/>
+          </a:ln>
+        </p:spPr>
+      </p:sp>
+      <p:sp>
+        <p:nvSpPr>
+          <p:cNvPr id="50" name="Text 48"/>
+          <p:cNvSpPr/>
+          <p:nvPr/>
+        </p:nvSpPr>
+        <p:spPr>
+          <a:xfrm>
+            <a:off x="7333488" y="2649266"/>
+            <a:ext cx="1645920" cy="420624"/>
+          </a:xfrm>
+          <a:prstGeom prst="rect">
+            <a:avLst/>
+          </a:prstGeom>
+          <a:noFill/>
+          <a:ln/>
+        </p:spPr>
+        <p:txBody>
+          <a:bodyPr wrap="square" lIns="0" tIns="0" rIns="0" bIns="0" rtlCol="0" anchor="ctr"/>
+          <a:lstStyle/>
+          <a:p>
+            <a:pPr algn="l" indent="0" marL="0">
+              <a:buNone/>
+            </a:pPr>
+            <a:r>
+              <a:rPr lang="en-US" sz="750" b="1" dirty="0">
+                <a:solidFill>
+                  <a:srgbClr val="E63946"/>
+                </a:solidFill>
+                <a:latin typeface="Calibri" pitchFamily="34" charset="0"/>
+                <a:ea typeface="Calibri" pitchFamily="34" charset="-122"/>
+                <a:cs typeface="Calibri" pitchFamily="34" charset="-120"/>
+              </a:rPr>
+              <a:t>← 25%</a:t>
+            </a:r>
+            <a:endParaRPr lang="en-US" sz="750" dirty="0"/>
+          </a:p>
+          <a:p>
+            <a:pPr algn="l" indent="0" marL="0">
+              <a:buNone/>
+            </a:pPr>
+            <a:r>
+              <a:rPr lang="en-US" sz="750" b="1" dirty="0">
+                <a:solidFill>
+                  <a:srgbClr val="E63946"/>
+                </a:solidFill>
+                <a:latin typeface="Calibri" pitchFamily="34" charset="0"/>
+                <a:ea typeface="Calibri" pitchFamily="34" charset="-122"/>
+                <a:cs typeface="Calibri" pitchFamily="34" charset="-120"/>
+              </a:rPr>
+              <a:t>chance</a:t>
+            </a:r>
+            <a:endParaRPr lang="en-US" sz="750" dirty="0"/>
+          </a:p>
+        </p:txBody>
+      </p:sp>
+      <p:sp>
+        <p:nvSpPr>
+          <p:cNvPr id="51" name="Shape 49"/>
+          <p:cNvSpPr/>
+          <p:nvPr/>
+        </p:nvSpPr>
+        <p:spPr>
+          <a:xfrm>
+            <a:off x="7333488" y="1216152"/>
+            <a:ext cx="201168" cy="164592"/>
+          </a:xfrm>
+          <a:prstGeom prst="rect">
+            <a:avLst/>
+          </a:prstGeom>
+          <a:solidFill>
+            <a:srgbClr val="1E5FAD"/>
+          </a:solidFill>
+          <a:ln w="12700">
+            <a:solidFill>
+              <a:srgbClr val="1E5FAD"/>
+            </a:solidFill>
+            <a:prstDash val="solid"/>
+          </a:ln>
+        </p:spPr>
+      </p:sp>
+      <p:sp>
+        <p:nvSpPr>
+          <p:cNvPr id="52" name="Text 50"/>
+          <p:cNvSpPr/>
+          <p:nvPr/>
+        </p:nvSpPr>
+        <p:spPr>
+          <a:xfrm>
+            <a:off x="7580376" y="1188720"/>
+            <a:ext cx="1371600" cy="219456"/>
+          </a:xfrm>
+          <a:prstGeom prst="rect">
+            <a:avLst/>
+          </a:prstGeom>
+          <a:noFill/>
+          <a:ln/>
+        </p:spPr>
+        <p:txBody>
+          <a:bodyPr wrap="square" lIns="0" tIns="0" rIns="0" bIns="0" rtlCol="0" anchor="ctr"/>
+          <a:lstStyle/>
+          <a:p>
+            <a:pPr indent="0" marL="0">
+              <a:buNone/>
+            </a:pPr>
+            <a:r>
+              <a:rPr lang="en-US" sz="900" dirty="0">
+                <a:solidFill>
+                  <a:srgbClr val="0D1B2A"/>
+                </a:solidFill>
+                <a:latin typeface="Calibri" pitchFamily="34" charset="0"/>
+                <a:ea typeface="Calibri" pitchFamily="34" charset="-122"/>
+                <a:cs typeface="Calibri" pitchFamily="34" charset="-120"/>
+              </a:rPr>
+              <a:t>Val bacc</a:t>
+            </a:r>
+            <a:endParaRPr lang="en-US" sz="900" dirty="0"/>
+          </a:p>
+        </p:txBody>
+      </p:sp>
+      <p:sp>
+        <p:nvSpPr>
+          <p:cNvPr id="53" name="Shape 51"/>
+          <p:cNvSpPr/>
+          <p:nvPr/>
+        </p:nvSpPr>
+        <p:spPr>
+          <a:xfrm>
+            <a:off x="7333488" y="1490472"/>
+            <a:ext cx="201168" cy="164592"/>
+          </a:xfrm>
+          <a:prstGeom prst="rect">
+            <a:avLst/>
+          </a:prstGeom>
+          <a:solidFill>
+            <a:srgbClr val="2EC4B6"/>
+          </a:solidFill>
+          <a:ln w="12700">
+            <a:solidFill>
+              <a:srgbClr val="2EC4B6"/>
+            </a:solidFill>
+            <a:prstDash val="solid"/>
+          </a:ln>
+        </p:spPr>
+      </p:sp>
+      <p:sp>
+        <p:nvSpPr>
+          <p:cNvPr id="54" name="Text 52"/>
+          <p:cNvSpPr/>
+          <p:nvPr/>
+        </p:nvSpPr>
+        <p:spPr>
+          <a:xfrm>
+            <a:off x="7580376" y="1463040"/>
+            <a:ext cx="1371600" cy="219456"/>
+          </a:xfrm>
+          <a:prstGeom prst="rect">
+            <a:avLst/>
+          </a:prstGeom>
+          <a:noFill/>
+          <a:ln/>
+        </p:spPr>
+        <p:txBody>
+          <a:bodyPr wrap="square" lIns="0" tIns="0" rIns="0" bIns="0" rtlCol="0" anchor="ctr"/>
+          <a:lstStyle/>
+          <a:p>
+            <a:pPr indent="0" marL="0">
+              <a:buNone/>
+            </a:pPr>
+            <a:r>
+              <a:rPr lang="en-US" sz="900" dirty="0">
+                <a:solidFill>
+                  <a:srgbClr val="0D1B2A"/>
+                </a:solidFill>
+                <a:latin typeface="Calibri" pitchFamily="34" charset="0"/>
+                <a:ea typeface="Calibri" pitchFamily="34" charset="-122"/>
+                <a:cs typeface="Calibri" pitchFamily="34" charset="-120"/>
+              </a:rPr>
+              <a:t>Test bacc</a:t>
+            </a:r>
+            <a:endParaRPr lang="en-US" sz="900" dirty="0"/>
+          </a:p>
+        </p:txBody>
+      </p:sp>
+      <p:sp>
+        <p:nvSpPr>
+          <p:cNvPr id="55" name="Shape 53"/>
+          <p:cNvSpPr/>
+          <p:nvPr/>
+        </p:nvSpPr>
+        <p:spPr>
+          <a:xfrm>
+            <a:off x="7333488" y="1856232"/>
+            <a:ext cx="1645920" cy="1371600"/>
+          </a:xfrm>
+          <a:prstGeom prst="roundRect">
+            <a:avLst>
+              <a:gd name="adj" fmla="val 5333"/>
+            </a:avLst>
+          </a:prstGeom>
+          <a:solidFill>
+            <a:srgbClr val="FFB703">
+              <a:alpha val="12000"/>
+            </a:srgbClr>
+          </a:solidFill>
+          <a:ln w="19050">
+            <a:solidFill>
+              <a:srgbClr val="FFB703"/>
+            </a:solidFill>
+            <a:prstDash val="solid"/>
+          </a:ln>
+        </p:spPr>
+      </p:sp>
+      <p:sp>
+        <p:nvSpPr>
+          <p:cNvPr id="56" name="Text 54"/>
+          <p:cNvSpPr/>
+          <p:nvPr/>
+        </p:nvSpPr>
+        <p:spPr>
+          <a:xfrm>
+            <a:off x="7379208" y="1965960"/>
+            <a:ext cx="1554480" cy="274320"/>
+          </a:xfrm>
+          <a:prstGeom prst="rect">
+            <a:avLst/>
+          </a:prstGeom>
+          <a:noFill/>
+          <a:ln/>
+        </p:spPr>
+        <p:txBody>
+          <a:bodyPr wrap="square" lIns="0" tIns="0" rIns="0" bIns="0" rtlCol="0" anchor="ctr"/>
+          <a:lstStyle/>
+          <a:p>
+            <a:pPr algn="ctr" indent="0" marL="0">
+              <a:buNone/>
+            </a:pPr>
+            <a:r>
+              <a:rPr lang="en-US" sz="1000" b="1" dirty="0">
+                <a:solidFill>
+                  <a:srgbClr val="FFB703"/>
+                </a:solidFill>
+                <a:latin typeface="Calibri" pitchFamily="34" charset="0"/>
+                <a:ea typeface="Calibri" pitchFamily="34" charset="-122"/>
+                <a:cs typeface="Calibri" pitchFamily="34" charset="-120"/>
+              </a:rPr>
+              <a:t>⚠ Overfit</a:t>
+            </a:r>
+            <a:endParaRPr lang="en-US" sz="1000" dirty="0"/>
+          </a:p>
+        </p:txBody>
+      </p:sp>
+      <p:sp>
+        <p:nvSpPr>
+          <p:cNvPr id="57" name="Text 55"/>
+          <p:cNvSpPr/>
+          <p:nvPr/>
+        </p:nvSpPr>
+        <p:spPr>
+          <a:xfrm>
+            <a:off x="7379208" y="2258568"/>
+            <a:ext cx="1554480" cy="822960"/>
+          </a:xfrm>
+          <a:prstGeom prst="rect">
+            <a:avLst/>
+          </a:prstGeom>
+          <a:noFill/>
+          <a:ln/>
+        </p:spPr>
+        <p:txBody>
+          <a:bodyPr wrap="square" lIns="0" tIns="0" rIns="0" bIns="0" rtlCol="0" anchor="ctr"/>
+          <a:lstStyle/>
+          <a:p>
+            <a:pPr algn="ctr" indent="0" marL="0">
+              <a:buNone/>
+            </a:pPr>
+            <a:r>
+              <a:rPr lang="en-US" sz="900" dirty="0">
+                <a:solidFill>
+                  <a:srgbClr val="0D1B2A"/>
+                </a:solidFill>
+                <a:latin typeface="Calibri" pitchFamily="34" charset="0"/>
+                <a:ea typeface="Calibri" pitchFamily="34" charset="-122"/>
+                <a:cs typeface="Calibri" pitchFamily="34" charset="-120"/>
+              </a:rPr>
+              <a:t>Train acc</a:t>
+            </a:r>
+            <a:endParaRPr lang="en-US" sz="900" dirty="0"/>
+          </a:p>
+          <a:p>
+            <a:pPr algn="ctr" indent="0" marL="0">
+              <a:buNone/>
+            </a:pPr>
+            <a:r>
+              <a:rPr lang="en-US" sz="900" dirty="0">
+                <a:solidFill>
+                  <a:srgbClr val="0D1B2A"/>
+                </a:solidFill>
+                <a:latin typeface="Calibri" pitchFamily="34" charset="0"/>
+                <a:ea typeface="Calibri" pitchFamily="34" charset="-122"/>
+                <a:cs typeface="Calibri" pitchFamily="34" charset="-120"/>
+              </a:rPr>
+              <a:t>60–99%</a:t>
+            </a:r>
+            <a:endParaRPr lang="en-US" sz="900" dirty="0"/>
+          </a:p>
+          <a:p>
+            <a:pPr algn="ctr" indent="0" marL="0">
+              <a:buNone/>
+            </a:pPr>
+            <a:r>
+              <a:rPr lang="en-US" sz="900" dirty="0">
+                <a:solidFill>
+                  <a:srgbClr val="0D1B2A"/>
+                </a:solidFill>
+                <a:latin typeface="Calibri" pitchFamily="34" charset="0"/>
+                <a:ea typeface="Calibri" pitchFamily="34" charset="-122"/>
+                <a:cs typeface="Calibri" pitchFamily="34" charset="-120"/>
+              </a:rPr>
+              <a:t>(vs 25–30% val)</a:t>
+            </a:r>
+            <a:endParaRPr lang="en-US" sz="900" dirty="0"/>
+          </a:p>
+        </p:txBody>
+      </p:sp>
+      <p:sp>
+        <p:nvSpPr>
+          <p:cNvPr id="58" name="Shape 56"/>
+          <p:cNvSpPr/>
+          <p:nvPr/>
+        </p:nvSpPr>
+        <p:spPr>
+          <a:xfrm>
+            <a:off x="365760" y="4133088"/>
+            <a:ext cx="8412480" cy="594360"/>
+          </a:xfrm>
+          <a:prstGeom prst="roundRect">
+            <a:avLst>
+              <a:gd name="adj" fmla="val 12308"/>
+            </a:avLst>
+          </a:prstGeom>
+          <a:solidFill>
+            <a:srgbClr val="2EC4B6">
+              <a:alpha val="12000"/>
+            </a:srgbClr>
+          </a:solidFill>
+          <a:ln w="19050">
+            <a:solidFill>
+              <a:srgbClr val="2EC4B6"/>
+            </a:solidFill>
+            <a:prstDash val="solid"/>
+          </a:ln>
+        </p:spPr>
+      </p:sp>
+      <p:sp>
+        <p:nvSpPr>
+          <p:cNvPr id="59" name="Text 57"/>
+          <p:cNvSpPr/>
+          <p:nvPr/>
+        </p:nvSpPr>
+        <p:spPr>
+          <a:xfrm>
+            <a:off x="548640" y="4178808"/>
+            <a:ext cx="8046720" cy="502920"/>
+          </a:xfrm>
+          <a:prstGeom prst="rect">
+            <a:avLst/>
+          </a:prstGeom>
+          <a:noFill/>
+          <a:ln/>
+        </p:spPr>
+        <p:txBody>
+          <a:bodyPr wrap="square" lIns="0" tIns="0" rIns="0" bIns="0" rtlCol="0" anchor="ctr"/>
+          <a:lstStyle/>
+          <a:p>
+            <a:pPr algn="ctr" indent="0" marL="0">
+              <a:buNone/>
+            </a:pPr>
+            <a:r>
+              <a:rPr lang="en-US" sz="1050" b="1" dirty="0">
+                <a:solidFill>
+                  <a:srgbClr val="2EC4B6"/>
+                </a:solidFill>
+                <a:latin typeface="Calibri" pitchFamily="34" charset="0"/>
+                <a:ea typeface="Calibri" pitchFamily="34" charset="-122"/>
+                <a:cs typeface="Calibri" pitchFamily="34" charset="-120"/>
+              </a:rPr>
+              <a:t>✓  EEG is decodable per-subject (val 27–30% &gt; 25% chance)  |  ShallowFBCSP best: 30.0%  |  Overfitting to train sessions = key bottleneck</a:t>
+            </a:r>
+            <a:endParaRPr lang="en-US" sz="1050" dirty="0"/>
+          </a:p>
+        </p:txBody>
+      </p:sp>
+    </p:spTree>
+  </p:cSld>
+  <p:clrMapOvr>
+    <a:masterClrMapping/>
+  </p:clrMapOvr>
+</p:sld>
+</file>
+
 <file path=ppt/slides/slide2.xml><?xml version="1.0" encoding="utf-8"?>
 <p:sld xmlns:a="http://schemas.openxmlformats.org/drawingml/2006/main" xmlns:r="http://schemas.openxmlformats.org/officeDocument/2006/relationships" xmlns:p="http://schemas.openxmlformats.org/presentationml/2006/main">
   <p:cSld name="Slide 2">

</xml_diff>